<commit_message>
Reorganized the local repo
</commit_message>
<xml_diff>
--- a/slides_lspm_officiel.pptx
+++ b/slides_lspm_officiel.pptx
@@ -5,15 +5,24 @@
     <p:sldMasterId id="2147483663" r:id="rId1"/>
   </p:sldMasterIdLst>
   <p:notesMasterIdLst>
-    <p:notesMasterId r:id="rId5"/>
+    <p:notesMasterId r:id="rId14"/>
   </p:notesMasterIdLst>
   <p:handoutMasterIdLst>
-    <p:handoutMasterId r:id="rId6"/>
+    <p:handoutMasterId r:id="rId15"/>
   </p:handoutMasterIdLst>
   <p:sldIdLst>
     <p:sldId id="256" r:id="rId2"/>
     <p:sldId id="257" r:id="rId3"/>
-    <p:sldId id="259" r:id="rId4"/>
+    <p:sldId id="260" r:id="rId4"/>
+    <p:sldId id="261" r:id="rId5"/>
+    <p:sldId id="262" r:id="rId6"/>
+    <p:sldId id="263" r:id="rId7"/>
+    <p:sldId id="264" r:id="rId8"/>
+    <p:sldId id="265" r:id="rId9"/>
+    <p:sldId id="266" r:id="rId10"/>
+    <p:sldId id="267" r:id="rId11"/>
+    <p:sldId id="268" r:id="rId12"/>
+    <p:sldId id="259" r:id="rId13"/>
   </p:sldIdLst>
   <p:sldSz cx="9144000" cy="6858000" type="screen4x3"/>
   <p:notesSz cx="6781800" cy="9926638"/>
@@ -144,7 +153,7 @@
   </p:defaultTextStyle>
   <p:extLst>
     <p:ext uri="{EFAFB233-063F-42B5-8137-9DF3F51BA10A}">
-      <p15:sldGuideLst xmlns="" xmlns:p15="http://schemas.microsoft.com/office/powerpoint/2012/main">
+      <p15:sldGuideLst xmlns:p15="http://schemas.microsoft.com/office/powerpoint/2012/main">
         <p15:guide id="1" orient="horz" pos="2160">
           <p15:clr>
             <a:srgbClr val="A4A3A4"/>
@@ -258,7 +267,7 @@
               <a:pPr>
                 <a:defRPr/>
               </a:pPr>
-              <a:t>19/11/2020</a:t>
+              <a:t>01/07/2024</a:t>
             </a:fld>
             <a:endParaRPr lang="en-GB"/>
           </a:p>
@@ -339,7 +348,7 @@
               <a:pPr>
                 <a:defRPr/>
               </a:pPr>
-              <a:t>‹N°›</a:t>
+              <a:t>‹#›</a:t>
             </a:fld>
             <a:endParaRPr lang="en-GB"/>
           </a:p>
@@ -643,35 +652,35 @@
           <a:p>
             <a:pPr lvl="0"/>
             <a:r>
-              <a:rPr lang="en-US" noProof="0" smtClean="0"/>
+              <a:rPr lang="en-US" noProof="0"/>
               <a:t>Cliquez pour modifier les styles du texte du masque</a:t>
             </a:r>
           </a:p>
           <a:p>
             <a:pPr lvl="1"/>
             <a:r>
-              <a:rPr lang="en-US" noProof="0" smtClean="0"/>
+              <a:rPr lang="en-US" noProof="0"/>
               <a:t>Deuxième niveau</a:t>
             </a:r>
           </a:p>
           <a:p>
             <a:pPr lvl="2"/>
             <a:r>
-              <a:rPr lang="en-US" noProof="0" smtClean="0"/>
+              <a:rPr lang="en-US" noProof="0"/>
               <a:t>Troisième niveau</a:t>
             </a:r>
           </a:p>
           <a:p>
             <a:pPr lvl="3"/>
             <a:r>
-              <a:rPr lang="en-US" noProof="0" smtClean="0"/>
+              <a:rPr lang="en-US" noProof="0"/>
               <a:t>Quatrième niveau</a:t>
             </a:r>
           </a:p>
           <a:p>
             <a:pPr lvl="4"/>
             <a:r>
-              <a:rPr lang="en-US" noProof="0" smtClean="0"/>
+              <a:rPr lang="en-US" noProof="0"/>
               <a:t>Cinquième niveau</a:t>
             </a:r>
           </a:p>
@@ -826,7 +835,7 @@
               <a:pPr>
                 <a:defRPr/>
               </a:pPr>
-              <a:t>‹N°›</a:t>
+              <a:t>‹#›</a:t>
             </a:fld>
             <a:endParaRPr lang="en-US"/>
           </a:p>
@@ -1006,7 +1015,7 @@
           <a:lstStyle/>
           <a:p>
             <a:r>
-              <a:rPr lang="fr-FR" dirty="0" smtClean="0"/>
+              <a:rPr lang="fr-FR" dirty="0"/>
               <a:t>Modifiez le style du titre</a:t>
             </a:r>
             <a:endParaRPr lang="en-GB" dirty="0"/>
@@ -1138,7 +1147,7 @@
           </a:lstStyle>
           <a:p>
             <a:r>
-              <a:rPr lang="fr-FR" dirty="0" smtClean="0"/>
+              <a:rPr lang="fr-FR" dirty="0"/>
               <a:t>Modifiez le style des sous-titres du masque</a:t>
             </a:r>
           </a:p>
@@ -1408,7 +1417,7 @@
           <a:p>
             <a:pPr lvl="0"/>
             <a:r>
-              <a:rPr lang="fr-FR" dirty="0" smtClean="0"/>
+              <a:rPr lang="fr-FR" dirty="0"/>
               <a:t>Modifier les styles du texte du masque</a:t>
             </a:r>
           </a:p>
@@ -1584,13 +1593,6 @@
   <p:clrMapOvr>
     <a:masterClrMapping/>
   </p:clrMapOvr>
-  <p:timing>
-    <p:tnLst>
-      <p:par>
-        <p:cTn id="1" dur="indefinite" restart="never" nodeType="tmRoot"/>
-      </p:par>
-    </p:tnLst>
-  </p:timing>
 </p:sldLayout>
 </file>
 
@@ -1636,7 +1638,7 @@
           </a:lstStyle>
           <a:p>
             <a:r>
-              <a:rPr lang="fr-FR" dirty="0" smtClean="0"/>
+              <a:rPr lang="fr-FR" dirty="0"/>
               <a:t>Modifiez le style du titre</a:t>
             </a:r>
             <a:endParaRPr lang="en-GB" dirty="0"/>
@@ -1665,35 +1667,35 @@
           <a:p>
             <a:pPr lvl="0"/>
             <a:r>
-              <a:rPr lang="fr-FR" smtClean="0"/>
+              <a:rPr lang="fr-FR"/>
               <a:t>Modifiez les styles du texte du masque</a:t>
             </a:r>
           </a:p>
           <a:p>
             <a:pPr lvl="1"/>
             <a:r>
-              <a:rPr lang="fr-FR" smtClean="0"/>
+              <a:rPr lang="fr-FR"/>
               <a:t>Deuxième niveau</a:t>
             </a:r>
           </a:p>
           <a:p>
             <a:pPr lvl="2"/>
             <a:r>
-              <a:rPr lang="fr-FR" smtClean="0"/>
+              <a:rPr lang="fr-FR"/>
               <a:t>Troisième niveau</a:t>
             </a:r>
           </a:p>
           <a:p>
             <a:pPr lvl="3"/>
             <a:r>
-              <a:rPr lang="fr-FR" smtClean="0"/>
+              <a:rPr lang="fr-FR"/>
               <a:t>Quatrième niveau</a:t>
             </a:r>
           </a:p>
           <a:p>
             <a:pPr lvl="4"/>
             <a:r>
-              <a:rPr lang="fr-FR" smtClean="0"/>
+              <a:rPr lang="fr-FR"/>
               <a:t>Cinquième niveau</a:t>
             </a:r>
             <a:endParaRPr lang="en-GB"/>
@@ -1798,10 +1800,9 @@
           </a:lstStyle>
           <a:p>
             <a:r>
-              <a:rPr lang="fr-FR" dirty="0" smtClean="0"/>
+              <a:rPr lang="fr-FR" dirty="0"/>
               <a:t>CONFERENCE - Ville, Pays - Date</a:t>
             </a:r>
-            <a:endParaRPr lang="fr-FR" dirty="0"/>
           </a:p>
         </p:txBody>
       </p:sp>
@@ -1837,7 +1838,7 @@
             <a:fld id="{BCB85A95-E1CC-4DC7-938C-5BF234670505}" type="slidenum">
               <a:rPr lang="fr-FR" smtClean="0"/>
               <a:pPr/>
-              <a:t>‹N°›</a:t>
+              <a:t>‹#›</a:t>
             </a:fld>
             <a:endParaRPr lang="fr-FR"/>
           </a:p>
@@ -2083,13 +2084,6 @@
   <p:clrMapOvr>
     <a:masterClrMapping/>
   </p:clrMapOvr>
-  <p:timing>
-    <p:tnLst>
-      <p:par>
-        <p:cTn id="1" dur="indefinite" restart="never" nodeType="tmRoot"/>
-      </p:par>
-    </p:tnLst>
-  </p:timing>
 </p:sldLayout>
 </file>
 
@@ -2131,7 +2125,7 @@
           <a:lstStyle/>
           <a:p>
             <a:r>
-              <a:rPr lang="fr-FR" dirty="0" smtClean="0"/>
+              <a:rPr lang="fr-FR" dirty="0"/>
               <a:t>Modifiez le style du titre</a:t>
             </a:r>
             <a:endParaRPr lang="en-GB" dirty="0"/>
@@ -2188,35 +2182,35 @@
           <a:p>
             <a:pPr lvl="0"/>
             <a:r>
-              <a:rPr lang="fr-FR" dirty="0" smtClean="0"/>
+              <a:rPr lang="fr-FR" dirty="0"/>
               <a:t>Modifiez les styles du texte du masque</a:t>
             </a:r>
           </a:p>
           <a:p>
             <a:pPr lvl="1"/>
             <a:r>
-              <a:rPr lang="fr-FR" dirty="0" smtClean="0"/>
+              <a:rPr lang="fr-FR" dirty="0"/>
               <a:t>Deuxième niveau</a:t>
             </a:r>
           </a:p>
           <a:p>
             <a:pPr lvl="2"/>
             <a:r>
-              <a:rPr lang="fr-FR" dirty="0" smtClean="0"/>
+              <a:rPr lang="fr-FR" dirty="0"/>
               <a:t>Troisième niveau</a:t>
             </a:r>
           </a:p>
           <a:p>
             <a:pPr lvl="3"/>
             <a:r>
-              <a:rPr lang="fr-FR" dirty="0" smtClean="0"/>
+              <a:rPr lang="fr-FR" dirty="0"/>
               <a:t>Quatrième niveau</a:t>
             </a:r>
           </a:p>
           <a:p>
             <a:pPr lvl="4"/>
             <a:r>
-              <a:rPr lang="fr-FR" dirty="0" smtClean="0"/>
+              <a:rPr lang="fr-FR" dirty="0"/>
               <a:t>Cinquième niveau</a:t>
             </a:r>
             <a:endParaRPr lang="en-GB" dirty="0"/>
@@ -2273,35 +2267,35 @@
           <a:p>
             <a:pPr lvl="0"/>
             <a:r>
-              <a:rPr lang="fr-FR" smtClean="0"/>
+              <a:rPr lang="fr-FR"/>
               <a:t>Modifiez les styles du texte du masque</a:t>
             </a:r>
           </a:p>
           <a:p>
             <a:pPr lvl="1"/>
             <a:r>
-              <a:rPr lang="fr-FR" smtClean="0"/>
+              <a:rPr lang="fr-FR"/>
               <a:t>Deuxième niveau</a:t>
             </a:r>
           </a:p>
           <a:p>
             <a:pPr lvl="2"/>
             <a:r>
-              <a:rPr lang="fr-FR" smtClean="0"/>
+              <a:rPr lang="fr-FR"/>
               <a:t>Troisième niveau</a:t>
             </a:r>
           </a:p>
           <a:p>
             <a:pPr lvl="3"/>
             <a:r>
-              <a:rPr lang="fr-FR" smtClean="0"/>
+              <a:rPr lang="fr-FR"/>
               <a:t>Quatrième niveau</a:t>
             </a:r>
           </a:p>
           <a:p>
             <a:pPr lvl="4"/>
             <a:r>
-              <a:rPr lang="fr-FR" smtClean="0"/>
+              <a:rPr lang="fr-FR"/>
               <a:t>Cinquième niveau</a:t>
             </a:r>
             <a:endParaRPr lang="en-GB"/>
@@ -2406,10 +2400,9 @@
           </a:lstStyle>
           <a:p>
             <a:r>
-              <a:rPr lang="fr-FR" dirty="0" smtClean="0"/>
+              <a:rPr lang="fr-FR" dirty="0"/>
               <a:t>CONFERENCE - Ville, Pays - Date</a:t>
             </a:r>
-            <a:endParaRPr lang="fr-FR" dirty="0"/>
           </a:p>
         </p:txBody>
       </p:sp>
@@ -2445,7 +2438,7 @@
             <a:fld id="{BCB85A95-E1CC-4DC7-938C-5BF234670505}" type="slidenum">
               <a:rPr lang="fr-FR" smtClean="0"/>
               <a:pPr/>
-              <a:t>‹N°›</a:t>
+              <a:t>‹#›</a:t>
             </a:fld>
             <a:endParaRPr lang="fr-FR"/>
           </a:p>
@@ -2691,13 +2684,6 @@
   <p:clrMapOvr>
     <a:masterClrMapping/>
   </p:clrMapOvr>
-  <p:timing>
-    <p:tnLst>
-      <p:par>
-        <p:cTn id="1" dur="indefinite" restart="never" nodeType="tmRoot"/>
-      </p:par>
-    </p:tnLst>
-  </p:timing>
 </p:sldLayout>
 </file>
 
@@ -2739,7 +2725,7 @@
           <a:lstStyle/>
           <a:p>
             <a:r>
-              <a:rPr lang="fr-FR" dirty="0" smtClean="0"/>
+              <a:rPr lang="fr-FR" dirty="0"/>
               <a:t>Modifiez le style du titre</a:t>
             </a:r>
             <a:endParaRPr lang="en-GB" dirty="0"/>
@@ -3030,7 +3016,7 @@
             <a:fld id="{BCB85A95-E1CC-4DC7-938C-5BF234670505}" type="slidenum">
               <a:rPr lang="fr-FR" smtClean="0"/>
               <a:pPr/>
-              <a:t>‹N°›</a:t>
+              <a:t>‹#›</a:t>
             </a:fld>
             <a:endParaRPr lang="fr-FR"/>
           </a:p>
@@ -3074,7 +3060,7 @@
           </a:lstStyle>
           <a:p>
             <a:r>
-              <a:rPr lang="fr-FR" smtClean="0"/>
+              <a:rPr lang="fr-FR"/>
               <a:t>CONFERENCE - Ville, Pays - Date</a:t>
             </a:r>
             <a:endParaRPr lang="fr-FR" dirty="0"/>
@@ -3145,13 +3131,6 @@
   <p:clrMapOvr>
     <a:masterClrMapping/>
   </p:clrMapOvr>
-  <p:timing>
-    <p:tnLst>
-      <p:par>
-        <p:cTn id="1" dur="indefinite" restart="never" nodeType="tmRoot"/>
-      </p:par>
-    </p:tnLst>
-  </p:timing>
 </p:sldLayout>
 </file>
 
@@ -3182,13 +3161,6 @@
   <p:clrMapOvr>
     <a:masterClrMapping/>
   </p:clrMapOvr>
-  <p:timing>
-    <p:tnLst>
-      <p:par>
-        <p:cTn id="1" dur="indefinite" restart="never" nodeType="tmRoot"/>
-      </p:par>
-    </p:tnLst>
-  </p:timing>
 </p:sldLayout>
 </file>
 
@@ -3261,7 +3233,6 @@
             <a:headEnd/>
             <a:tailEnd/>
           </a:ln>
-          <a:extLst/>
         </p:spPr>
         <p:txBody>
           <a:bodyPr vert="horz" wrap="square" lIns="91440" tIns="45720" rIns="91440" bIns="45720" numCol="1" anchor="b" anchorCtr="0" compatLnSpc="1">
@@ -3273,10 +3244,10 @@
           <a:p>
             <a:pPr lvl="0"/>
             <a:r>
-              <a:rPr lang="fr-FR" dirty="0" smtClean="0"/>
+              <a:rPr lang="fr-FR" dirty="0"/>
               <a:t>Modifiez le style du titre</a:t>
             </a:r>
-            <a:endParaRPr lang="en-GB" dirty="0" smtClean="0"/>
+            <a:endParaRPr lang="en-GB" dirty="0"/>
           </a:p>
         </p:txBody>
       </p:sp>
@@ -3332,38 +3303,38 @@
           <a:p>
             <a:pPr lvl="0"/>
             <a:r>
-              <a:rPr lang="fr-FR" smtClean="0"/>
+              <a:rPr lang="fr-FR"/>
               <a:t>Modifiez les styles du texte du masque</a:t>
             </a:r>
           </a:p>
           <a:p>
             <a:pPr lvl="1"/>
             <a:r>
-              <a:rPr lang="fr-FR" smtClean="0"/>
+              <a:rPr lang="fr-FR"/>
               <a:t>Deuxième niveau</a:t>
             </a:r>
           </a:p>
           <a:p>
             <a:pPr lvl="2"/>
             <a:r>
-              <a:rPr lang="fr-FR" smtClean="0"/>
+              <a:rPr lang="fr-FR"/>
               <a:t>Troisième niveau</a:t>
             </a:r>
           </a:p>
           <a:p>
             <a:pPr lvl="3"/>
             <a:r>
-              <a:rPr lang="fr-FR" smtClean="0"/>
+              <a:rPr lang="fr-FR"/>
               <a:t>Quatrième niveau</a:t>
             </a:r>
           </a:p>
           <a:p>
             <a:pPr lvl="4"/>
             <a:r>
-              <a:rPr lang="fr-FR" smtClean="0"/>
+              <a:rPr lang="fr-FR"/>
               <a:t>Cinquième niveau</a:t>
             </a:r>
-            <a:endParaRPr lang="en-GB" smtClean="0"/>
+            <a:endParaRPr lang="en-GB"/>
           </a:p>
         </p:txBody>
       </p:sp>
@@ -3401,10 +3372,9 @@
           </a:lstStyle>
           <a:p>
             <a:r>
-              <a:rPr lang="fr-FR" smtClean="0"/>
+              <a:rPr lang="fr-FR"/>
               <a:t>CONFERENCE - Ville, Pays - Date</a:t>
             </a:r>
-            <a:endParaRPr lang="fr-FR"/>
           </a:p>
         </p:txBody>
       </p:sp>
@@ -3444,7 +3414,7 @@
             <a:fld id="{BCB85A95-E1CC-4DC7-938C-5BF234670505}" type="slidenum">
               <a:rPr lang="fr-FR" smtClean="0"/>
               <a:pPr/>
-              <a:t>‹N°›</a:t>
+              <a:t>‹#›</a:t>
             </a:fld>
             <a:endParaRPr lang="fr-FR"/>
           </a:p>
@@ -3497,13 +3467,6 @@
     <p:sldLayoutId id="2147483944" r:id="rId4"/>
     <p:sldLayoutId id="2147483945" r:id="rId5"/>
   </p:sldLayoutIdLst>
-  <p:timing>
-    <p:tnLst>
-      <p:par>
-        <p:cTn id="1" dur="indefinite" restart="never" nodeType="tmRoot"/>
-      </p:par>
-    </p:tnLst>
-  </p:timing>
   <p:hf hdr="0" dt="0"/>
   <p:txStyles>
     <p:titleStyle>
@@ -3921,19 +3884,15 @@
         </p:spPr>
         <p:txBody>
           <a:bodyPr>
-            <a:normAutofit/>
+            <a:noAutofit/>
           </a:bodyPr>
           <a:lstStyle/>
           <a:p>
             <a:r>
-              <a:rPr lang="fr-FR" dirty="0" smtClean="0">
-                <a:solidFill>
-                  <a:srgbClr val="FF0000"/>
-                </a:solidFill>
-              </a:rPr>
-              <a:t>Titre de la présentation</a:t>
-            </a:r>
-            <a:endParaRPr lang="fr-FR" dirty="0">
+              <a:rPr lang="fr-FR" sz="2600" dirty="0"/>
+              <a:t>Étude des structures et de la cinétique de croissance d’édifices atomiques par dynamique moléculaire classique</a:t>
+            </a:r>
+            <a:endParaRPr lang="fr-FR" sz="2600" dirty="0">
               <a:solidFill>
                 <a:srgbClr val="FF0000"/>
               </a:solidFill>
@@ -3990,43 +3949,30 @@
           <a:lstStyle/>
           <a:p>
             <a:r>
-              <a:rPr lang="fr-FR" sz="2800" dirty="0" smtClean="0">
-                <a:solidFill>
-                  <a:srgbClr val="FF0000"/>
-                </a:solidFill>
-              </a:rPr>
-              <a:t>Noms des auteurs, </a:t>
-            </a:r>
-          </a:p>
-          <a:p>
-            <a:endParaRPr lang="fr-FR" sz="2800" dirty="0" smtClean="0"/>
-          </a:p>
-          <a:p>
-            <a:r>
-              <a:rPr lang="fr-FR" sz="2800" dirty="0" smtClean="0"/>
+              <a:rPr lang="fr-FR" sz="2800" dirty="0"/>
+              <a:t>Assann DEDE, Jonathan MOUGENOT</a:t>
+            </a:r>
+          </a:p>
+          <a:p>
+            <a:endParaRPr lang="fr-FR" sz="2800" dirty="0"/>
+          </a:p>
+          <a:p>
+            <a:r>
+              <a:rPr lang="fr-FR" sz="2800" dirty="0"/>
               <a:t>LSPM UPR 3407 – CNRS</a:t>
             </a:r>
           </a:p>
           <a:p>
             <a:r>
-              <a:rPr lang="fr-FR" sz="1900" dirty="0" smtClean="0"/>
+              <a:rPr lang="fr-FR" sz="1900" dirty="0"/>
               <a:t>99 avenue Jean-Baptiste Clément, F-93430 Villetaneuse</a:t>
             </a:r>
           </a:p>
           <a:p>
             <a:r>
-              <a:rPr lang="fr-FR" sz="1900" dirty="0" smtClean="0">
-                <a:solidFill>
-                  <a:srgbClr val="FF0000"/>
-                </a:solidFill>
-              </a:rPr>
-              <a:t>prénom.nom</a:t>
-            </a:r>
-            <a:r>
-              <a:rPr lang="fr-FR" sz="1900" dirty="0" smtClean="0"/>
-              <a:t>@lspm.cnrs.fr</a:t>
-            </a:r>
-            <a:endParaRPr lang="fr-FR" sz="1900" dirty="0"/>
+              <a:rPr lang="fr-FR" sz="1900" dirty="0"/>
+              <a:t>Jonathan.mougenot@lspm.cnrs.fr</a:t>
+            </a:r>
           </a:p>
           <a:p>
             <a:endParaRPr lang="fr-FR" dirty="0"/>
@@ -4048,34 +3994,49 @@
           <a:bodyPr/>
           <a:lstStyle/>
           <a:p>
-            <a:r>
-              <a:rPr lang="fr-FR" dirty="0" smtClean="0">
-                <a:solidFill>
-                  <a:srgbClr val="FF0000"/>
-                </a:solidFill>
-              </a:rPr>
-              <a:t>Nom de la conférence, lieu, date</a:t>
-            </a:r>
-            <a:endParaRPr lang="fr-FR" dirty="0">
-              <a:solidFill>
-                <a:srgbClr val="FF0000"/>
-              </a:solidFill>
-            </a:endParaRPr>
+            <a:pPr>
+              <a:spcAft>
+                <a:spcPts val="600"/>
+              </a:spcAft>
+            </a:pPr>
+            <a:r>
+              <a:rPr lang="fr-FR" dirty="0"/>
+              <a:t>Soutenance de stage, LSPM, le 4 juillet 2024</a:t>
+            </a:r>
           </a:p>
         </p:txBody>
       </p:sp>
-      <p:sp>
-        <p:nvSpPr>
-          <p:cNvPr id="5" name="Espace réservé pour une image  4"/>
-          <p:cNvSpPr>
-            <a:spLocks noGrp="1"/>
-          </p:cNvSpPr>
+      <p:pic>
+        <p:nvPicPr>
+          <p:cNvPr id="9" name="Picture Placeholder 8" descr="A blue molecule model on a black background&#10;&#10;Description automatically generated">
+            <a:extLst>
+              <a:ext uri="{FF2B5EF4-FFF2-40B4-BE49-F238E27FC236}">
+                <a16:creationId xmlns:a16="http://schemas.microsoft.com/office/drawing/2014/main" id="{536DC93B-715E-AB1D-9B63-2D25DEF54107}"/>
+              </a:ext>
+            </a:extLst>
+          </p:cNvPr>
+          <p:cNvPicPr>
+            <a:picLocks noGrp="1" noChangeAspect="1"/>
+          </p:cNvPicPr>
           <p:nvPr>
             <p:ph type="pic" sz="quarter" idx="11"/>
           </p:nvPr>
-        </p:nvSpPr>
+        </p:nvPicPr>
+        <p:blipFill>
+          <a:blip r:embed="rId2">
+            <a:extLst>
+              <a:ext uri="{28A0092B-C50C-407E-A947-70E740481C1C}">
+                <a14:useLocalDpi xmlns:a14="http://schemas.microsoft.com/office/drawing/2010/main" val="0"/>
+              </a:ext>
+            </a:extLst>
+          </a:blip>
+          <a:srcRect l="12500" r="12500"/>
+          <a:stretch>
+            <a:fillRect/>
+          </a:stretch>
+        </p:blipFill>
         <p:spPr/>
-      </p:sp>
+      </p:pic>
     </p:spTree>
     <p:extLst>
       <p:ext uri="{BB962C8B-B14F-4D97-AF65-F5344CB8AC3E}">
@@ -4086,17 +4047,10 @@
   <p:clrMapOvr>
     <a:masterClrMapping/>
   </p:clrMapOvr>
-  <p:timing>
-    <p:tnLst>
-      <p:par>
-        <p:cTn id="1" dur="indefinite" restart="never" nodeType="tmRoot"/>
-      </p:par>
-    </p:tnLst>
-  </p:timing>
 </p:sld>
 </file>
 
-<file path=ppt/slides/slide2.xml><?xml version="1.0" encoding="utf-8"?>
+<file path=ppt/slides/slide10.xml><?xml version="1.0" encoding="utf-8"?>
 <p:sld xmlns:a="http://schemas.openxmlformats.org/drawingml/2006/main" xmlns:r="http://schemas.openxmlformats.org/officeDocument/2006/relationships" xmlns:p="http://schemas.openxmlformats.org/presentationml/2006/main">
   <p:cSld>
     <p:spTree>
@@ -4115,7 +4069,301 @@
       </p:grpSpPr>
       <p:sp>
         <p:nvSpPr>
-          <p:cNvPr id="4" name="Titre 3"/>
+          <p:cNvPr id="12" name="Title 1">
+            <a:extLst>
+              <a:ext uri="{FF2B5EF4-FFF2-40B4-BE49-F238E27FC236}">
+                <a16:creationId xmlns:a16="http://schemas.microsoft.com/office/drawing/2014/main" id="{095177EF-0C51-D409-60DF-F27A7B8715F6}"/>
+              </a:ext>
+            </a:extLst>
+          </p:cNvPr>
+          <p:cNvSpPr>
+            <a:spLocks noGrp="1"/>
+          </p:cNvSpPr>
+          <p:nvPr>
+            <p:ph type="title"/>
+          </p:nvPr>
+        </p:nvSpPr>
+        <p:spPr>
+          <a:xfrm>
+            <a:off x="323528" y="188640"/>
+            <a:ext cx="8568952" cy="792088"/>
+          </a:xfrm>
+        </p:spPr>
+        <p:txBody>
+          <a:bodyPr/>
+          <a:lstStyle/>
+          <a:p>
+            <a:r>
+              <a:rPr lang="en-US" sz="3600" dirty="0"/>
+              <a:t>Clusters de Carbone les plus stables</a:t>
+            </a:r>
+          </a:p>
+        </p:txBody>
+      </p:sp>
+      <p:pic>
+        <p:nvPicPr>
+          <p:cNvPr id="7" name="Content Placeholder 6">
+            <a:extLst>
+              <a:ext uri="{FF2B5EF4-FFF2-40B4-BE49-F238E27FC236}">
+                <a16:creationId xmlns:a16="http://schemas.microsoft.com/office/drawing/2014/main" id="{189E0CED-690B-2E62-C16C-4E33C7A0851E}"/>
+              </a:ext>
+            </a:extLst>
+          </p:cNvPr>
+          <p:cNvPicPr>
+            <a:picLocks noGrp="1" noChangeAspect="1"/>
+          </p:cNvPicPr>
+          <p:nvPr>
+            <p:ph sz="half" idx="1"/>
+          </p:nvPr>
+        </p:nvPicPr>
+        <p:blipFill>
+          <a:blip r:embed="rId2"/>
+          <a:stretch>
+            <a:fillRect/>
+          </a:stretch>
+        </p:blipFill>
+        <p:spPr>
+          <a:xfrm>
+            <a:off x="251520" y="1270564"/>
+            <a:ext cx="4244280" cy="4750723"/>
+          </a:xfrm>
+          <a:noFill/>
+        </p:spPr>
+      </p:pic>
+      <p:sp>
+        <p:nvSpPr>
+          <p:cNvPr id="14" name="Content Placeholder 3">
+            <a:extLst>
+              <a:ext uri="{FF2B5EF4-FFF2-40B4-BE49-F238E27FC236}">
+                <a16:creationId xmlns:a16="http://schemas.microsoft.com/office/drawing/2014/main" id="{8EFD5FB7-1011-CEBE-494C-F5424D862189}"/>
+              </a:ext>
+            </a:extLst>
+          </p:cNvPr>
+          <p:cNvSpPr>
+            <a:spLocks noGrp="1"/>
+          </p:cNvSpPr>
+          <p:nvPr>
+            <p:ph sz="half" idx="2"/>
+          </p:nvPr>
+        </p:nvSpPr>
+        <p:spPr>
+          <a:xfrm>
+            <a:off x="4648200" y="1270564"/>
+            <a:ext cx="4244280" cy="4855602"/>
+          </a:xfrm>
+        </p:spPr>
+        <p:txBody>
+          <a:bodyPr/>
+          <a:lstStyle/>
+          <a:p>
+            <a:r>
+              <a:rPr lang="fr-FR" sz="2600" dirty="0">
+                <a:latin typeface="Times New Roman" panose="02020603050405020304" pitchFamily="18" charset="0"/>
+                <a:cs typeface="Times New Roman" panose="02020603050405020304" pitchFamily="18" charset="0"/>
+              </a:rPr>
+              <a:t>Les clusters linéaires (C2 à C5)</a:t>
+            </a:r>
+          </a:p>
+          <a:p>
+            <a:r>
+              <a:rPr lang="fr-FR" sz="2600" dirty="0">
+                <a:latin typeface="Times New Roman" panose="02020603050405020304" pitchFamily="18" charset="0"/>
+                <a:cs typeface="Times New Roman" panose="02020603050405020304" pitchFamily="18" charset="0"/>
+              </a:rPr>
+              <a:t>Les clusters monocycliques (C6 à C15)</a:t>
+            </a:r>
+          </a:p>
+          <a:p>
+            <a:r>
+              <a:rPr lang="fr-FR" sz="2600" dirty="0">
+                <a:latin typeface="Times New Roman" panose="02020603050405020304" pitchFamily="18" charset="0"/>
+                <a:cs typeface="Times New Roman" panose="02020603050405020304" pitchFamily="18" charset="0"/>
+              </a:rPr>
+              <a:t>Les </a:t>
+            </a:r>
+            <a:r>
+              <a:rPr lang="fr-FR" sz="2600" dirty="0" err="1">
+                <a:latin typeface="Times New Roman" panose="02020603050405020304" pitchFamily="18" charset="0"/>
+                <a:cs typeface="Times New Roman" panose="02020603050405020304" pitchFamily="18" charset="0"/>
+              </a:rPr>
+              <a:t>polycycles</a:t>
+            </a:r>
+            <a:r>
+              <a:rPr lang="fr-FR" sz="2600" dirty="0">
+                <a:latin typeface="Times New Roman" panose="02020603050405020304" pitchFamily="18" charset="0"/>
+                <a:cs typeface="Times New Roman" panose="02020603050405020304" pitchFamily="18" charset="0"/>
+              </a:rPr>
+              <a:t> (C16 à C19)</a:t>
+            </a:r>
+          </a:p>
+          <a:p>
+            <a:r>
+              <a:rPr lang="fr-FR" sz="2600" dirty="0">
+                <a:latin typeface="Times New Roman" panose="02020603050405020304" pitchFamily="18" charset="0"/>
+                <a:cs typeface="Times New Roman" panose="02020603050405020304" pitchFamily="18" charset="0"/>
+              </a:rPr>
+              <a:t>Les graphènes-like (C20 à C29)</a:t>
+            </a:r>
+          </a:p>
+          <a:p>
+            <a:r>
+              <a:rPr lang="en-US" sz="2600" dirty="0">
+                <a:latin typeface="Times New Roman" panose="02020603050405020304" pitchFamily="18" charset="0"/>
+                <a:cs typeface="Times New Roman" panose="02020603050405020304" pitchFamily="18" charset="0"/>
+              </a:rPr>
+              <a:t>Les 3D-polycycles et bowl</a:t>
+            </a:r>
+          </a:p>
+          <a:p>
+            <a:r>
+              <a:rPr lang="en-US" sz="2600" dirty="0">
+                <a:latin typeface="Times New Roman" panose="02020603050405020304" pitchFamily="18" charset="0"/>
+                <a:cs typeface="Times New Roman" panose="02020603050405020304" pitchFamily="18" charset="0"/>
+              </a:rPr>
+              <a:t>Les </a:t>
+            </a:r>
+            <a:r>
+              <a:rPr lang="en-US" sz="2600" dirty="0" err="1">
+                <a:latin typeface="Times New Roman" panose="02020603050405020304" pitchFamily="18" charset="0"/>
+                <a:cs typeface="Times New Roman" panose="02020603050405020304" pitchFamily="18" charset="0"/>
+              </a:rPr>
+              <a:t>fullerènes</a:t>
+            </a:r>
+            <a:r>
+              <a:rPr lang="en-US" sz="2600" dirty="0">
+                <a:latin typeface="Times New Roman" panose="02020603050405020304" pitchFamily="18" charset="0"/>
+                <a:cs typeface="Times New Roman" panose="02020603050405020304" pitchFamily="18" charset="0"/>
+              </a:rPr>
+              <a:t>-like</a:t>
+            </a:r>
+          </a:p>
+        </p:txBody>
+      </p:sp>
+      <p:sp>
+        <p:nvSpPr>
+          <p:cNvPr id="4" name="Footer Placeholder 3">
+            <a:extLst>
+              <a:ext uri="{FF2B5EF4-FFF2-40B4-BE49-F238E27FC236}">
+                <a16:creationId xmlns:a16="http://schemas.microsoft.com/office/drawing/2014/main" id="{AB990B41-4255-1427-23A9-F0C94B6AA0BA}"/>
+              </a:ext>
+            </a:extLst>
+          </p:cNvPr>
+          <p:cNvSpPr>
+            <a:spLocks noGrp="1"/>
+          </p:cNvSpPr>
+          <p:nvPr>
+            <p:ph type="ftr" sz="quarter" idx="11"/>
+          </p:nvPr>
+        </p:nvSpPr>
+        <p:spPr>
+          <a:xfrm>
+            <a:off x="2627784" y="6356350"/>
+            <a:ext cx="5400600" cy="365125"/>
+          </a:xfrm>
+        </p:spPr>
+        <p:txBody>
+          <a:bodyPr anchor="ctr">
+            <a:normAutofit/>
+          </a:bodyPr>
+          <a:lstStyle/>
+          <a:p>
+            <a:pPr>
+              <a:spcAft>
+                <a:spcPts val="600"/>
+              </a:spcAft>
+            </a:pPr>
+            <a:r>
+              <a:rPr lang="fr-FR"/>
+              <a:t>CONFERENCE - Ville, Pays - Date</a:t>
+            </a:r>
+          </a:p>
+        </p:txBody>
+      </p:sp>
+      <p:sp>
+        <p:nvSpPr>
+          <p:cNvPr id="5" name="Slide Number Placeholder 4">
+            <a:extLst>
+              <a:ext uri="{FF2B5EF4-FFF2-40B4-BE49-F238E27FC236}">
+                <a16:creationId xmlns:a16="http://schemas.microsoft.com/office/drawing/2014/main" id="{D75F66DD-D4A0-50AE-FD76-77A323092308}"/>
+              </a:ext>
+            </a:extLst>
+          </p:cNvPr>
+          <p:cNvSpPr>
+            <a:spLocks noGrp="1"/>
+          </p:cNvSpPr>
+          <p:nvPr>
+            <p:ph type="sldNum" sz="quarter" idx="12"/>
+          </p:nvPr>
+        </p:nvSpPr>
+        <p:spPr>
+          <a:xfrm>
+            <a:off x="8172400" y="6356350"/>
+            <a:ext cx="717848" cy="365125"/>
+          </a:xfrm>
+        </p:spPr>
+        <p:txBody>
+          <a:bodyPr anchor="ctr">
+            <a:normAutofit/>
+          </a:bodyPr>
+          <a:lstStyle/>
+          <a:p>
+            <a:pPr>
+              <a:spcAft>
+                <a:spcPts val="600"/>
+              </a:spcAft>
+            </a:pPr>
+            <a:fld id="{BCB85A95-E1CC-4DC7-938C-5BF234670505}" type="slidenum">
+              <a:rPr lang="fr-FR" smtClean="0"/>
+              <a:pPr>
+                <a:spcAft>
+                  <a:spcPts val="600"/>
+                </a:spcAft>
+              </a:pPr>
+              <a:t>10</a:t>
+            </a:fld>
+            <a:endParaRPr lang="fr-FR"/>
+          </a:p>
+        </p:txBody>
+      </p:sp>
+    </p:spTree>
+    <p:extLst>
+      <p:ext uri="{BB962C8B-B14F-4D97-AF65-F5344CB8AC3E}">
+        <p14:creationId xmlns:p14="http://schemas.microsoft.com/office/powerpoint/2010/main" val="1805119570"/>
+      </p:ext>
+    </p:extLst>
+  </p:cSld>
+  <p:clrMapOvr>
+    <a:masterClrMapping/>
+  </p:clrMapOvr>
+</p:sld>
+</file>
+
+<file path=ppt/slides/slide11.xml><?xml version="1.0" encoding="utf-8"?>
+<p:sld xmlns:a="http://schemas.openxmlformats.org/drawingml/2006/main" xmlns:r="http://schemas.openxmlformats.org/officeDocument/2006/relationships" xmlns:p="http://schemas.openxmlformats.org/presentationml/2006/main">
+  <p:cSld>
+    <p:spTree>
+      <p:nvGrpSpPr>
+        <p:cNvPr id="1" name=""/>
+        <p:cNvGrpSpPr/>
+        <p:nvPr/>
+      </p:nvGrpSpPr>
+      <p:grpSpPr>
+        <a:xfrm>
+          <a:off x="0" y="0"/>
+          <a:ext cx="0" cy="0"/>
+          <a:chOff x="0" y="0"/>
+          <a:chExt cx="0" cy="0"/>
+        </a:xfrm>
+      </p:grpSpPr>
+      <p:sp>
+        <p:nvSpPr>
+          <p:cNvPr id="2" name="Title 1">
+            <a:extLst>
+              <a:ext uri="{FF2B5EF4-FFF2-40B4-BE49-F238E27FC236}">
+                <a16:creationId xmlns:a16="http://schemas.microsoft.com/office/drawing/2014/main" id="{44754705-CC59-97C9-A010-CB1B94E55B4F}"/>
+              </a:ext>
+            </a:extLst>
+          </p:cNvPr>
           <p:cNvSpPr>
             <a:spLocks noGrp="1"/>
           </p:cNvSpPr>
@@ -4128,17 +4376,73 @@
           <a:bodyPr/>
           <a:lstStyle/>
           <a:p>
-            <a:r>
-              <a:rPr lang="fr-FR" dirty="0" smtClean="0"/>
-              <a:t>Contexte</a:t>
-            </a:r>
-            <a:endParaRPr lang="fr-FR" dirty="0"/>
+            <a:endParaRPr lang="fr-FR"/>
           </a:p>
         </p:txBody>
       </p:sp>
       <p:sp>
         <p:nvSpPr>
-          <p:cNvPr id="6" name="Espace réservé du numéro de diapositive 5"/>
+          <p:cNvPr id="3" name="Content Placeholder 2">
+            <a:extLst>
+              <a:ext uri="{FF2B5EF4-FFF2-40B4-BE49-F238E27FC236}">
+                <a16:creationId xmlns:a16="http://schemas.microsoft.com/office/drawing/2014/main" id="{0078F31F-7B82-6F66-6F59-31F8C54E6DF5}"/>
+              </a:ext>
+            </a:extLst>
+          </p:cNvPr>
+          <p:cNvSpPr>
+            <a:spLocks noGrp="1"/>
+          </p:cNvSpPr>
+          <p:nvPr>
+            <p:ph idx="1"/>
+          </p:nvPr>
+        </p:nvSpPr>
+        <p:spPr/>
+        <p:txBody>
+          <a:bodyPr/>
+          <a:lstStyle/>
+          <a:p>
+            <a:endParaRPr lang="fr-FR"/>
+          </a:p>
+        </p:txBody>
+      </p:sp>
+      <p:sp>
+        <p:nvSpPr>
+          <p:cNvPr id="4" name="Footer Placeholder 3">
+            <a:extLst>
+              <a:ext uri="{FF2B5EF4-FFF2-40B4-BE49-F238E27FC236}">
+                <a16:creationId xmlns:a16="http://schemas.microsoft.com/office/drawing/2014/main" id="{34916910-3054-C635-6E8D-6FF9260B72A2}"/>
+              </a:ext>
+            </a:extLst>
+          </p:cNvPr>
+          <p:cNvSpPr>
+            <a:spLocks noGrp="1"/>
+          </p:cNvSpPr>
+          <p:nvPr>
+            <p:ph type="ftr" sz="quarter" idx="11"/>
+          </p:nvPr>
+        </p:nvSpPr>
+        <p:spPr/>
+        <p:txBody>
+          <a:bodyPr/>
+          <a:lstStyle/>
+          <a:p>
+            <a:r>
+              <a:rPr lang="fr-FR"/>
+              <a:t>CONFERENCE - Ville, Pays - Date</a:t>
+            </a:r>
+            <a:endParaRPr lang="fr-FR" dirty="0"/>
+          </a:p>
+        </p:txBody>
+      </p:sp>
+      <p:sp>
+        <p:nvSpPr>
+          <p:cNvPr id="5" name="Slide Number Placeholder 4">
+            <a:extLst>
+              <a:ext uri="{FF2B5EF4-FFF2-40B4-BE49-F238E27FC236}">
+                <a16:creationId xmlns:a16="http://schemas.microsoft.com/office/drawing/2014/main" id="{661A306D-58E4-CC98-D937-316FE0862AD0}"/>
+              </a:ext>
+            </a:extLst>
+          </p:cNvPr>
           <p:cNvSpPr>
             <a:spLocks noGrp="1"/>
           </p:cNvSpPr>
@@ -4154,59 +4458,26 @@
             <a:fld id="{BCB85A95-E1CC-4DC7-938C-5BF234670505}" type="slidenum">
               <a:rPr lang="fr-FR" smtClean="0"/>
               <a:pPr/>
-              <a:t>2</a:t>
+              <a:t>11</a:t>
             </a:fld>
             <a:endParaRPr lang="fr-FR"/>
-          </a:p>
-        </p:txBody>
-      </p:sp>
-      <p:sp>
-        <p:nvSpPr>
-          <p:cNvPr id="7" name="Espace réservé du pied de page 6"/>
-          <p:cNvSpPr>
-            <a:spLocks noGrp="1"/>
-          </p:cNvSpPr>
-          <p:nvPr>
-            <p:ph type="ftr" sz="quarter" idx="11"/>
-          </p:nvPr>
-        </p:nvSpPr>
-        <p:spPr/>
-        <p:txBody>
-          <a:bodyPr/>
-          <a:lstStyle/>
-          <a:p>
-            <a:r>
-              <a:rPr lang="fr-FR" dirty="0">
-                <a:solidFill>
-                  <a:srgbClr val="FF0000"/>
-                </a:solidFill>
-              </a:rPr>
-              <a:t>Nom de la conférence, lieu, date</a:t>
-            </a:r>
           </a:p>
         </p:txBody>
       </p:sp>
     </p:spTree>
     <p:extLst>
       <p:ext uri="{BB962C8B-B14F-4D97-AF65-F5344CB8AC3E}">
-        <p14:creationId xmlns:p14="http://schemas.microsoft.com/office/powerpoint/2010/main" val="1063674581"/>
+        <p14:creationId xmlns:p14="http://schemas.microsoft.com/office/powerpoint/2010/main" val="1063819418"/>
       </p:ext>
     </p:extLst>
   </p:cSld>
   <p:clrMapOvr>
     <a:masterClrMapping/>
   </p:clrMapOvr>
-  <p:timing>
-    <p:tnLst>
-      <p:par>
-        <p:cTn id="1" dur="indefinite" restart="never" nodeType="tmRoot"/>
-      </p:par>
-    </p:tnLst>
-  </p:timing>
 </p:sld>
 </file>
 
-<file path=ppt/slides/slide3.xml><?xml version="1.0" encoding="utf-8"?>
+<file path=ppt/slides/slide12.xml><?xml version="1.0" encoding="utf-8"?>
 <p:sld xmlns:a="http://schemas.openxmlformats.org/drawingml/2006/main" xmlns:r="http://schemas.openxmlformats.org/officeDocument/2006/relationships" xmlns:p="http://schemas.openxmlformats.org/presentationml/2006/main">
   <p:cSld>
     <p:spTree>
@@ -4242,10 +4513,9 @@
           <a:p>
             <a:pPr algn="ctr"/>
             <a:r>
-              <a:rPr lang="fr-FR" sz="4000" dirty="0" smtClean="0"/>
+              <a:rPr lang="fr-FR" sz="4000" dirty="0"/>
               <a:t>Merci de votre attention</a:t>
             </a:r>
-            <a:endParaRPr lang="fr-FR" sz="4000" dirty="0"/>
           </a:p>
         </p:txBody>
       </p:sp>
@@ -4268,22 +4538,16 @@
           <a:p>
             <a:pPr algn="l"/>
             <a:r>
-              <a:rPr lang="fr-FR" dirty="0" smtClean="0"/>
+              <a:rPr lang="fr-FR" dirty="0"/>
               <a:t>LSPM - CNRS</a:t>
             </a:r>
-            <a:endParaRPr lang="fr-FR" dirty="0"/>
           </a:p>
           <a:p>
             <a:pPr algn="l"/>
             <a:r>
               <a:rPr lang="fr-FR" dirty="0"/>
-              <a:t>Université </a:t>
-            </a:r>
-            <a:r>
-              <a:rPr lang="fr-FR" dirty="0" smtClean="0"/>
-              <a:t>Sorbonne Paris Nord</a:t>
-            </a:r>
-            <a:endParaRPr lang="fr-FR" dirty="0"/>
+              <a:t>Université Sorbonne Paris Nord</a:t>
+            </a:r>
           </a:p>
           <a:p>
             <a:pPr algn="l"/>
@@ -4296,20 +4560,15 @@
             <a:pPr algn="l"/>
             <a:r>
               <a:rPr lang="fr-FR" dirty="0"/>
-              <a:t>93430 </a:t>
-            </a:r>
-            <a:r>
-              <a:rPr lang="fr-FR" dirty="0" smtClean="0"/>
-              <a:t>Villetaneuse</a:t>
+              <a:t>93430 Villetaneuse</a:t>
             </a:r>
           </a:p>
           <a:p>
             <a:pPr algn="l"/>
             <a:r>
-              <a:rPr lang="fr-FR" dirty="0" smtClean="0"/>
+              <a:rPr lang="fr-FR" dirty="0"/>
               <a:t>France</a:t>
             </a:r>
-            <a:endParaRPr lang="fr-FR" dirty="0"/>
           </a:p>
           <a:p>
             <a:pPr algn="l"/>
@@ -4337,11 +4596,11 @@
               </a:tabLst>
             </a:pPr>
             <a:r>
-              <a:rPr lang="fr-FR" dirty="0" smtClean="0"/>
+              <a:rPr lang="fr-FR" dirty="0"/>
               <a:t>Tel: 	+33 1 49 40 </a:t>
             </a:r>
             <a:r>
-              <a:rPr lang="fr-FR" dirty="0" smtClean="0">
+              <a:rPr lang="fr-FR" dirty="0">
                 <a:solidFill>
                   <a:srgbClr val="FF0000"/>
                 </a:solidFill>
@@ -4349,14 +4608,14 @@
               <a:t>xx </a:t>
             </a:r>
             <a:r>
-              <a:rPr lang="fr-FR" dirty="0" err="1" smtClean="0">
+              <a:rPr lang="fr-FR" dirty="0" err="1">
                 <a:solidFill>
                   <a:srgbClr val="FF0000"/>
                 </a:solidFill>
               </a:rPr>
               <a:t>xx</a:t>
             </a:r>
-            <a:endParaRPr lang="fr-FR" dirty="0" smtClean="0">
+            <a:endParaRPr lang="fr-FR" dirty="0">
               <a:solidFill>
                 <a:srgbClr val="FF0000"/>
               </a:solidFill>
@@ -4369,26 +4628,9 @@
               </a:tabLst>
             </a:pPr>
             <a:r>
-              <a:rPr lang="fr-FR" dirty="0" smtClean="0"/>
-              <a:t>Fax</a:t>
-            </a:r>
-            <a:r>
               <a:rPr lang="fr-FR" dirty="0"/>
-              <a:t>: </a:t>
-            </a:r>
-            <a:r>
-              <a:rPr lang="fr-FR" dirty="0" smtClean="0"/>
-              <a:t>	+</a:t>
-            </a:r>
-            <a:r>
-              <a:rPr lang="fr-FR" dirty="0"/>
-              <a:t>33 1 49 40 34 </a:t>
-            </a:r>
-            <a:r>
-              <a:rPr lang="fr-FR" dirty="0" smtClean="0"/>
-              <a:t>14</a:t>
-            </a:r>
-            <a:endParaRPr lang="fr-FR" dirty="0"/>
+              <a:t>Fax: 	+33 1 49 40 34 14</a:t>
+            </a:r>
           </a:p>
         </p:txBody>
       </p:sp>
@@ -4453,13 +4695,3038 @@
   <p:clrMapOvr>
     <a:masterClrMapping/>
   </p:clrMapOvr>
+</p:sld>
+</file>
+
+<file path=ppt/slides/slide2.xml><?xml version="1.0" encoding="utf-8"?>
+<p:sld xmlns:a="http://schemas.openxmlformats.org/drawingml/2006/main" xmlns:r="http://schemas.openxmlformats.org/officeDocument/2006/relationships" xmlns:p="http://schemas.openxmlformats.org/presentationml/2006/main">
+  <p:cSld>
+    <p:spTree>
+      <p:nvGrpSpPr>
+        <p:cNvPr id="1" name=""/>
+        <p:cNvGrpSpPr/>
+        <p:nvPr/>
+      </p:nvGrpSpPr>
+      <p:grpSpPr>
+        <a:xfrm>
+          <a:off x="0" y="0"/>
+          <a:ext cx="0" cy="0"/>
+          <a:chOff x="0" y="0"/>
+          <a:chExt cx="0" cy="0"/>
+        </a:xfrm>
+      </p:grpSpPr>
+      <p:sp>
+        <p:nvSpPr>
+          <p:cNvPr id="4" name="Titre 3"/>
+          <p:cNvSpPr>
+            <a:spLocks noGrp="1"/>
+          </p:cNvSpPr>
+          <p:nvPr>
+            <p:ph type="title"/>
+          </p:nvPr>
+        </p:nvSpPr>
+        <p:spPr>
+          <a:xfrm>
+            <a:off x="323528" y="188640"/>
+            <a:ext cx="8566720" cy="792088"/>
+          </a:xfrm>
+        </p:spPr>
+        <p:txBody>
+          <a:bodyPr wrap="square" anchor="b">
+            <a:noAutofit/>
+          </a:bodyPr>
+          <a:lstStyle/>
+          <a:p>
+            <a:r>
+              <a:rPr lang="en-US" sz="3600" dirty="0"/>
+              <a:t>La </a:t>
+            </a:r>
+            <a:r>
+              <a:rPr lang="fr-FR" sz="3600" dirty="0"/>
+              <a:t>Dynamique</a:t>
+            </a:r>
+            <a:r>
+              <a:rPr lang="en-US" sz="3600" dirty="0"/>
+              <a:t> </a:t>
+            </a:r>
+            <a:r>
+              <a:rPr lang="fr-FR" sz="3600" dirty="0"/>
+              <a:t>Moléculaire classique</a:t>
+            </a:r>
+          </a:p>
+        </p:txBody>
+      </p:sp>
+      <p:sp>
+        <p:nvSpPr>
+          <p:cNvPr id="7" name="Espace réservé du pied de page 6"/>
+          <p:cNvSpPr>
+            <a:spLocks noGrp="1"/>
+          </p:cNvSpPr>
+          <p:nvPr>
+            <p:ph type="ftr" sz="quarter" idx="11"/>
+          </p:nvPr>
+        </p:nvSpPr>
+        <p:spPr>
+          <a:xfrm>
+            <a:off x="2627784" y="6356350"/>
+            <a:ext cx="5400600" cy="365125"/>
+          </a:xfrm>
+        </p:spPr>
+        <p:txBody>
+          <a:bodyPr anchor="ctr">
+            <a:normAutofit/>
+          </a:bodyPr>
+          <a:lstStyle/>
+          <a:p>
+            <a:pPr>
+              <a:spcAft>
+                <a:spcPts val="600"/>
+              </a:spcAft>
+            </a:pPr>
+            <a:r>
+              <a:rPr lang="fr-FR" dirty="0"/>
+              <a:t>Soutenance de stage, LSPM, le 4 juillet 2024</a:t>
+            </a:r>
+          </a:p>
+        </p:txBody>
+      </p:sp>
+      <p:sp>
+        <p:nvSpPr>
+          <p:cNvPr id="6" name="Espace réservé du numéro de diapositive 5"/>
+          <p:cNvSpPr>
+            <a:spLocks noGrp="1"/>
+          </p:cNvSpPr>
+          <p:nvPr>
+            <p:ph type="sldNum" sz="quarter" idx="12"/>
+          </p:nvPr>
+        </p:nvSpPr>
+        <p:spPr>
+          <a:xfrm>
+            <a:off x="8172400" y="6343334"/>
+            <a:ext cx="717848" cy="378141"/>
+          </a:xfrm>
+        </p:spPr>
+        <p:txBody>
+          <a:bodyPr anchor="ctr">
+            <a:normAutofit/>
+          </a:bodyPr>
+          <a:lstStyle/>
+          <a:p>
+            <a:pPr>
+              <a:spcAft>
+                <a:spcPts val="600"/>
+              </a:spcAft>
+            </a:pPr>
+            <a:fld id="{BCB85A95-E1CC-4DC7-938C-5BF234670505}" type="slidenum">
+              <a:rPr lang="fr-FR" smtClean="0"/>
+              <a:pPr>
+                <a:spcAft>
+                  <a:spcPts val="600"/>
+                </a:spcAft>
+              </a:pPr>
+              <a:t>2</a:t>
+            </a:fld>
+            <a:endParaRPr lang="fr-FR"/>
+          </a:p>
+        </p:txBody>
+      </p:sp>
+      <p:pic>
+        <p:nvPicPr>
+          <p:cNvPr id="5" name="Simulation dynamique moléculaire_480p">
+            <a:hlinkClick r:id="" action="ppaction://media"/>
+            <a:extLst>
+              <a:ext uri="{FF2B5EF4-FFF2-40B4-BE49-F238E27FC236}">
+                <a16:creationId xmlns:a16="http://schemas.microsoft.com/office/drawing/2014/main" id="{32EE4CE9-6B23-7DAE-F59E-06C6D7B524AC}"/>
+              </a:ext>
+            </a:extLst>
+          </p:cNvPr>
+          <p:cNvPicPr>
+            <a:picLocks noChangeAspect="1"/>
+          </p:cNvPicPr>
+          <p:nvPr>
+            <a:videoFile r:link="rId2"/>
+            <p:extLst>
+              <p:ext uri="{DAA4B4D4-6D71-4841-9C94-3DE7FCFB9230}">
+                <p14:media xmlns:p14="http://schemas.microsoft.com/office/powerpoint/2010/main" r:embed="rId1"/>
+              </p:ext>
+            </p:extLst>
+          </p:nvPr>
+        </p:nvPicPr>
+        <p:blipFill rotWithShape="1">
+          <a:blip r:embed="rId4"/>
+          <a:srcRect l="21651" r="11407" b="5900"/>
+          <a:stretch/>
+        </p:blipFill>
+        <p:spPr>
+          <a:xfrm>
+            <a:off x="4932040" y="1196752"/>
+            <a:ext cx="4080792" cy="3960440"/>
+          </a:xfrm>
+          <a:prstGeom prst="rect">
+            <a:avLst/>
+          </a:prstGeom>
+        </p:spPr>
+      </p:pic>
+      <p:sp>
+        <p:nvSpPr>
+          <p:cNvPr id="8" name="TextBox 7">
+            <a:extLst>
+              <a:ext uri="{FF2B5EF4-FFF2-40B4-BE49-F238E27FC236}">
+                <a16:creationId xmlns:a16="http://schemas.microsoft.com/office/drawing/2014/main" id="{9A359F0A-BEBA-CAD2-43FE-7D3B57E26145}"/>
+              </a:ext>
+            </a:extLst>
+          </p:cNvPr>
+          <p:cNvSpPr txBox="1"/>
+          <p:nvPr/>
+        </p:nvSpPr>
+        <p:spPr>
+          <a:xfrm>
+            <a:off x="541112" y="1434909"/>
+            <a:ext cx="4080792" cy="1200329"/>
+          </a:xfrm>
+          <a:prstGeom prst="rect">
+            <a:avLst/>
+          </a:prstGeom>
+          <a:noFill/>
+        </p:spPr>
+        <p:txBody>
+          <a:bodyPr wrap="square" rtlCol="0">
+            <a:spAutoFit/>
+          </a:bodyPr>
+          <a:lstStyle/>
+          <a:p>
+            <a:pPr marL="285750" indent="-285750" algn="just">
+              <a:buFont typeface="Arial" panose="020B0604020202020204" pitchFamily="34" charset="0"/>
+              <a:buChar char="•"/>
+            </a:pPr>
+            <a:r>
+              <a:rPr lang="fr-FR" dirty="0">
+                <a:latin typeface="Times New Roman" panose="02020603050405020304" pitchFamily="18" charset="0"/>
+                <a:cs typeface="Times New Roman" panose="02020603050405020304" pitchFamily="18" charset="0"/>
+              </a:rPr>
+              <a:t>Méthode</a:t>
+            </a:r>
+            <a:r>
+              <a:rPr lang="en-US" dirty="0">
+                <a:latin typeface="Times New Roman" panose="02020603050405020304" pitchFamily="18" charset="0"/>
+                <a:cs typeface="Times New Roman" panose="02020603050405020304" pitchFamily="18" charset="0"/>
+              </a:rPr>
+              <a:t> de simulations numérique à </a:t>
+            </a:r>
+            <a:r>
+              <a:rPr lang="en-US" dirty="0" err="1">
+                <a:latin typeface="Times New Roman" panose="02020603050405020304" pitchFamily="18" charset="0"/>
+                <a:cs typeface="Times New Roman" panose="02020603050405020304" pitchFamily="18" charset="0"/>
+              </a:rPr>
+              <a:t>l'échelle</a:t>
+            </a:r>
+            <a:r>
+              <a:rPr lang="en-US" dirty="0">
+                <a:latin typeface="Times New Roman" panose="02020603050405020304" pitchFamily="18" charset="0"/>
+                <a:cs typeface="Times New Roman" panose="02020603050405020304" pitchFamily="18" charset="0"/>
+              </a:rPr>
+              <a:t> de </a:t>
+            </a:r>
+            <a:r>
+              <a:rPr lang="fr-FR" dirty="0">
+                <a:latin typeface="Times New Roman" panose="02020603050405020304" pitchFamily="18" charset="0"/>
+                <a:cs typeface="Times New Roman" panose="02020603050405020304" pitchFamily="18" charset="0"/>
+              </a:rPr>
+              <a:t>l’atome</a:t>
+            </a:r>
+          </a:p>
+          <a:p>
+            <a:pPr marL="285750" indent="-285750">
+              <a:buFont typeface="Arial" panose="020B0604020202020204" pitchFamily="34" charset="0"/>
+              <a:buChar char="•"/>
+            </a:pPr>
+            <a:r>
+              <a:rPr lang="en-US" dirty="0" err="1">
+                <a:latin typeface="Times New Roman" panose="02020603050405020304" pitchFamily="18" charset="0"/>
+                <a:cs typeface="Times New Roman" panose="02020603050405020304" pitchFamily="18" charset="0"/>
+              </a:rPr>
+              <a:t>Atomes</a:t>
+            </a:r>
+            <a:r>
+              <a:rPr lang="en-US" dirty="0">
+                <a:latin typeface="Times New Roman" panose="02020603050405020304" pitchFamily="18" charset="0"/>
+                <a:cs typeface="Times New Roman" panose="02020603050405020304" pitchFamily="18" charset="0"/>
+              </a:rPr>
+              <a:t> </a:t>
+            </a:r>
+            <a:r>
+              <a:rPr lang="en-US" dirty="0" err="1">
+                <a:latin typeface="Times New Roman" panose="02020603050405020304" pitchFamily="18" charset="0"/>
+                <a:cs typeface="Times New Roman" panose="02020603050405020304" pitchFamily="18" charset="0"/>
+              </a:rPr>
+              <a:t>soumis</a:t>
+            </a:r>
+            <a:r>
+              <a:rPr lang="en-US" dirty="0">
+                <a:latin typeface="Times New Roman" panose="02020603050405020304" pitchFamily="18" charset="0"/>
+                <a:cs typeface="Times New Roman" panose="02020603050405020304" pitchFamily="18" charset="0"/>
+              </a:rPr>
+              <a:t> à des forces</a:t>
+            </a:r>
+          </a:p>
+          <a:p>
+            <a:pPr marL="285750" indent="-285750">
+              <a:buFont typeface="Arial" panose="020B0604020202020204" pitchFamily="34" charset="0"/>
+              <a:buChar char="•"/>
+            </a:pPr>
+            <a:r>
+              <a:rPr lang="en-US" dirty="0" err="1">
+                <a:latin typeface="Times New Roman" panose="02020603050405020304" pitchFamily="18" charset="0"/>
+                <a:cs typeface="Times New Roman" panose="02020603050405020304" pitchFamily="18" charset="0"/>
+              </a:rPr>
+              <a:t>Logiciels</a:t>
+            </a:r>
+            <a:r>
+              <a:rPr lang="en-US" dirty="0">
+                <a:latin typeface="Times New Roman" panose="02020603050405020304" pitchFamily="18" charset="0"/>
+                <a:cs typeface="Times New Roman" panose="02020603050405020304" pitchFamily="18" charset="0"/>
+              </a:rPr>
+              <a:t> de simulation</a:t>
+            </a:r>
+          </a:p>
+        </p:txBody>
+      </p:sp>
+      <p:pic>
+        <p:nvPicPr>
+          <p:cNvPr id="10" name="Picture 9" descr="A green ball on a black background">
+            <a:extLst>
+              <a:ext uri="{FF2B5EF4-FFF2-40B4-BE49-F238E27FC236}">
+                <a16:creationId xmlns:a16="http://schemas.microsoft.com/office/drawing/2014/main" id="{D0FF155A-091E-2D37-FEDB-7E0D809B124D}"/>
+              </a:ext>
+            </a:extLst>
+          </p:cNvPr>
+          <p:cNvPicPr>
+            <a:picLocks noChangeAspect="1"/>
+          </p:cNvPicPr>
+          <p:nvPr/>
+        </p:nvPicPr>
+        <p:blipFill>
+          <a:blip r:embed="rId5" cstate="print">
+            <a:extLst>
+              <a:ext uri="{28A0092B-C50C-407E-A947-70E740481C1C}">
+                <a14:useLocalDpi xmlns:a14="http://schemas.microsoft.com/office/drawing/2010/main" val="0"/>
+              </a:ext>
+            </a:extLst>
+          </a:blip>
+          <a:stretch>
+            <a:fillRect/>
+          </a:stretch>
+        </p:blipFill>
+        <p:spPr>
+          <a:xfrm>
+            <a:off x="1115616" y="3192524"/>
+            <a:ext cx="2376264" cy="801974"/>
+          </a:xfrm>
+          <a:prstGeom prst="rect">
+            <a:avLst/>
+          </a:prstGeom>
+        </p:spPr>
+      </p:pic>
+      <p:pic>
+        <p:nvPicPr>
+          <p:cNvPr id="12" name="Picture 11" descr="A blue and yellow dots&#10;&#10;Description automatically generated">
+            <a:extLst>
+              <a:ext uri="{FF2B5EF4-FFF2-40B4-BE49-F238E27FC236}">
+                <a16:creationId xmlns:a16="http://schemas.microsoft.com/office/drawing/2014/main" id="{4D2B84DE-6C03-FD1B-00E2-6FC37E066815}"/>
+              </a:ext>
+            </a:extLst>
+          </p:cNvPr>
+          <p:cNvPicPr>
+            <a:picLocks noChangeAspect="1"/>
+          </p:cNvPicPr>
+          <p:nvPr/>
+        </p:nvPicPr>
+        <p:blipFill>
+          <a:blip r:embed="rId6">
+            <a:extLst>
+              <a:ext uri="{28A0092B-C50C-407E-A947-70E740481C1C}">
+                <a14:useLocalDpi xmlns:a14="http://schemas.microsoft.com/office/drawing/2010/main" val="0"/>
+              </a:ext>
+            </a:extLst>
+          </a:blip>
+          <a:stretch>
+            <a:fillRect/>
+          </a:stretch>
+        </p:blipFill>
+        <p:spPr>
+          <a:xfrm>
+            <a:off x="554361" y="4551784"/>
+            <a:ext cx="3657600" cy="1066800"/>
+          </a:xfrm>
+          <a:prstGeom prst="rect">
+            <a:avLst/>
+          </a:prstGeom>
+        </p:spPr>
+      </p:pic>
+    </p:spTree>
+    <p:extLst>
+      <p:ext uri="{BB962C8B-B14F-4D97-AF65-F5344CB8AC3E}">
+        <p14:creationId xmlns:p14="http://schemas.microsoft.com/office/powerpoint/2010/main" val="1063674581"/>
+      </p:ext>
+    </p:extLst>
+  </p:cSld>
+  <p:clrMapOvr>
+    <a:masterClrMapping/>
+  </p:clrMapOvr>
   <p:timing>
     <p:tnLst>
       <p:par>
-        <p:cTn id="1" dur="indefinite" restart="never" nodeType="tmRoot"/>
+        <p:cTn id="1" dur="indefinite" restart="never" nodeType="tmRoot">
+          <p:childTnLst>
+            <p:seq concurrent="1" nextAc="seek">
+              <p:cTn id="2" dur="indefinite" nodeType="mainSeq">
+                <p:childTnLst>
+                  <p:par>
+                    <p:cTn id="3" fill="hold">
+                      <p:stCondLst>
+                        <p:cond delay="indefinite"/>
+                        <p:cond evt="onBegin" delay="0">
+                          <p:tn val="2"/>
+                        </p:cond>
+                      </p:stCondLst>
+                      <p:childTnLst>
+                        <p:par>
+                          <p:cTn id="4" fill="hold">
+                            <p:stCondLst>
+                              <p:cond delay="0"/>
+                            </p:stCondLst>
+                            <p:childTnLst>
+                              <p:par>
+                                <p:cTn id="5" presetID="1" presetClass="mediacall" presetSubtype="0" fill="hold" nodeType="afterEffect">
+                                  <p:stCondLst>
+                                    <p:cond delay="0"/>
+                                  </p:stCondLst>
+                                  <p:childTnLst>
+                                    <p:cmd type="call" cmd="playFrom(0.0)">
+                                      <p:cBhvr>
+                                        <p:cTn id="6" dur="20063" fill="hold"/>
+                                        <p:tgtEl>
+                                          <p:spTgt spid="5"/>
+                                        </p:tgtEl>
+                                      </p:cBhvr>
+                                    </p:cmd>
+                                  </p:childTnLst>
+                                </p:cTn>
+                              </p:par>
+                            </p:childTnLst>
+                          </p:cTn>
+                        </p:par>
+                      </p:childTnLst>
+                    </p:cTn>
+                  </p:par>
+                </p:childTnLst>
+              </p:cTn>
+              <p:prevCondLst>
+                <p:cond evt="onPrev" delay="0">
+                  <p:tgtEl>
+                    <p:sldTgt/>
+                  </p:tgtEl>
+                </p:cond>
+              </p:prevCondLst>
+              <p:nextCondLst>
+                <p:cond evt="onNext" delay="0">
+                  <p:tgtEl>
+                    <p:sldTgt/>
+                  </p:tgtEl>
+                </p:cond>
+              </p:nextCondLst>
+            </p:seq>
+            <p:video>
+              <p:cMediaNode vol="80000" mute="1">
+                <p:cTn id="7" repeatCount="indefinite" fill="remove" display="0">
+                  <p:stCondLst>
+                    <p:cond delay="indefinite"/>
+                  </p:stCondLst>
+                </p:cTn>
+                <p:tgtEl>
+                  <p:spTgt spid="5"/>
+                </p:tgtEl>
+              </p:cMediaNode>
+            </p:video>
+            <p:seq concurrent="1" nextAc="seek">
+              <p:cTn id="8" restart="whenNotActive" fill="hold" evtFilter="cancelBubble" nodeType="interactiveSeq">
+                <p:stCondLst>
+                  <p:cond evt="onClick" delay="0">
+                    <p:tgtEl>
+                      <p:spTgt spid="5"/>
+                    </p:tgtEl>
+                  </p:cond>
+                </p:stCondLst>
+                <p:endSync evt="end" delay="0">
+                  <p:rtn val="all"/>
+                </p:endSync>
+                <p:childTnLst>
+                  <p:par>
+                    <p:cTn id="9" fill="hold">
+                      <p:stCondLst>
+                        <p:cond delay="0"/>
+                      </p:stCondLst>
+                      <p:childTnLst>
+                        <p:par>
+                          <p:cTn id="10" fill="hold">
+                            <p:stCondLst>
+                              <p:cond delay="0"/>
+                            </p:stCondLst>
+                            <p:childTnLst>
+                              <p:par>
+                                <p:cTn id="11" presetID="2" presetClass="mediacall" presetSubtype="0" fill="hold" nodeType="clickEffect">
+                                  <p:stCondLst>
+                                    <p:cond delay="0"/>
+                                  </p:stCondLst>
+                                  <p:childTnLst>
+                                    <p:cmd type="call" cmd="togglePause">
+                                      <p:cBhvr>
+                                        <p:cTn id="12" dur="1" fill="hold"/>
+                                        <p:tgtEl>
+                                          <p:spTgt spid="5"/>
+                                        </p:tgtEl>
+                                      </p:cBhvr>
+                                    </p:cmd>
+                                  </p:childTnLst>
+                                </p:cTn>
+                              </p:par>
+                            </p:childTnLst>
+                          </p:cTn>
+                        </p:par>
+                      </p:childTnLst>
+                    </p:cTn>
+                  </p:par>
+                </p:childTnLst>
+              </p:cTn>
+              <p:nextCondLst>
+                <p:cond evt="onClick" delay="0">
+                  <p:tgtEl>
+                    <p:spTgt spid="5"/>
+                  </p:tgtEl>
+                </p:cond>
+              </p:nextCondLst>
+            </p:seq>
+          </p:childTnLst>
+        </p:cTn>
       </p:par>
     </p:tnLst>
   </p:timing>
+</p:sld>
+</file>
+
+<file path=ppt/slides/slide3.xml><?xml version="1.0" encoding="utf-8"?>
+<p:sld xmlns:a="http://schemas.openxmlformats.org/drawingml/2006/main" xmlns:r="http://schemas.openxmlformats.org/officeDocument/2006/relationships" xmlns:p="http://schemas.openxmlformats.org/presentationml/2006/main">
+  <p:cSld>
+    <p:spTree>
+      <p:nvGrpSpPr>
+        <p:cNvPr id="1" name=""/>
+        <p:cNvGrpSpPr/>
+        <p:nvPr/>
+      </p:nvGrpSpPr>
+      <p:grpSpPr>
+        <a:xfrm>
+          <a:off x="0" y="0"/>
+          <a:ext cx="0" cy="0"/>
+          <a:chOff x="0" y="0"/>
+          <a:chExt cx="0" cy="0"/>
+        </a:xfrm>
+      </p:grpSpPr>
+      <p:sp>
+        <p:nvSpPr>
+          <p:cNvPr id="2" name="Title 1">
+            <a:extLst>
+              <a:ext uri="{FF2B5EF4-FFF2-40B4-BE49-F238E27FC236}">
+                <a16:creationId xmlns:a16="http://schemas.microsoft.com/office/drawing/2014/main" id="{4C9CE398-4883-DC9E-83ED-11D0F6DCC7D9}"/>
+              </a:ext>
+            </a:extLst>
+          </p:cNvPr>
+          <p:cNvSpPr>
+            <a:spLocks noGrp="1"/>
+          </p:cNvSpPr>
+          <p:nvPr>
+            <p:ph type="title"/>
+          </p:nvPr>
+        </p:nvSpPr>
+        <p:spPr/>
+        <p:txBody>
+          <a:bodyPr/>
+          <a:lstStyle/>
+          <a:p>
+            <a:r>
+              <a:rPr lang="en-US" dirty="0" err="1"/>
+              <a:t>Objectifs</a:t>
+            </a:r>
+            <a:r>
+              <a:rPr lang="en-US" dirty="0"/>
+              <a:t> du stage</a:t>
+            </a:r>
+            <a:endParaRPr lang="fr-FR" dirty="0"/>
+          </a:p>
+        </p:txBody>
+      </p:sp>
+      <p:sp>
+        <p:nvSpPr>
+          <p:cNvPr id="3" name="Content Placeholder 2">
+            <a:extLst>
+              <a:ext uri="{FF2B5EF4-FFF2-40B4-BE49-F238E27FC236}">
+                <a16:creationId xmlns:a16="http://schemas.microsoft.com/office/drawing/2014/main" id="{AB84C261-DAE0-99EB-B53B-B6536A3C49F6}"/>
+              </a:ext>
+            </a:extLst>
+          </p:cNvPr>
+          <p:cNvSpPr>
+            <a:spLocks noGrp="1"/>
+          </p:cNvSpPr>
+          <p:nvPr>
+            <p:ph idx="1"/>
+          </p:nvPr>
+        </p:nvSpPr>
+        <p:spPr/>
+        <p:txBody>
+          <a:bodyPr/>
+          <a:lstStyle/>
+          <a:p>
+            <a:r>
+              <a:rPr lang="en-US" dirty="0" err="1"/>
+              <a:t>Apprendre</a:t>
+            </a:r>
+            <a:r>
+              <a:rPr lang="en-US" dirty="0"/>
+              <a:t> à </a:t>
+            </a:r>
+            <a:r>
+              <a:rPr lang="en-US" dirty="0" err="1"/>
+              <a:t>utiliser</a:t>
+            </a:r>
+            <a:r>
+              <a:rPr lang="en-US" dirty="0"/>
+              <a:t> LAMMPS et OVITO</a:t>
+            </a:r>
+          </a:p>
+          <a:p>
+            <a:r>
+              <a:rPr lang="en-US" dirty="0" err="1"/>
+              <a:t>Reproduire</a:t>
+            </a:r>
+            <a:r>
+              <a:rPr lang="en-US" dirty="0"/>
+              <a:t> les clusters de </a:t>
+            </a:r>
+            <a:r>
+              <a:rPr lang="en-US" dirty="0" err="1"/>
+              <a:t>carbones</a:t>
+            </a:r>
+            <a:r>
+              <a:rPr lang="en-US" dirty="0"/>
+              <a:t> stables</a:t>
+            </a:r>
+          </a:p>
+          <a:p>
+            <a:r>
+              <a:rPr lang="en-US" dirty="0" err="1"/>
+              <a:t>Établir</a:t>
+            </a:r>
+            <a:r>
+              <a:rPr lang="en-US" dirty="0"/>
+              <a:t> les differences entre la liaison </a:t>
+            </a:r>
+            <a:r>
+              <a:rPr lang="en-US" dirty="0" err="1"/>
+              <a:t>métallique</a:t>
+            </a:r>
+            <a:r>
+              <a:rPr lang="en-US" dirty="0"/>
+              <a:t> et la liaison </a:t>
+            </a:r>
+            <a:r>
+              <a:rPr lang="en-US" dirty="0" err="1"/>
+              <a:t>covalente</a:t>
+            </a:r>
+            <a:endParaRPr lang="en-US" dirty="0"/>
+          </a:p>
+          <a:p>
+            <a:r>
+              <a:rPr lang="en-US" dirty="0" err="1"/>
+              <a:t>Modéliser</a:t>
+            </a:r>
+            <a:r>
+              <a:rPr lang="en-US" dirty="0"/>
+              <a:t> des clusters de </a:t>
+            </a:r>
+            <a:r>
+              <a:rPr lang="en-US" dirty="0" err="1"/>
+              <a:t>Tungstène</a:t>
+            </a:r>
+            <a:r>
+              <a:rPr lang="en-US" dirty="0"/>
+              <a:t> après exposition à stress </a:t>
+            </a:r>
+            <a:r>
+              <a:rPr lang="en-US" dirty="0" err="1"/>
+              <a:t>thermique</a:t>
+            </a:r>
+            <a:endParaRPr lang="fr-FR" dirty="0"/>
+          </a:p>
+        </p:txBody>
+      </p:sp>
+      <p:sp>
+        <p:nvSpPr>
+          <p:cNvPr id="4" name="Footer Placeholder 3">
+            <a:extLst>
+              <a:ext uri="{FF2B5EF4-FFF2-40B4-BE49-F238E27FC236}">
+                <a16:creationId xmlns:a16="http://schemas.microsoft.com/office/drawing/2014/main" id="{F2711F74-683A-AA53-D85C-B4639852FE45}"/>
+              </a:ext>
+            </a:extLst>
+          </p:cNvPr>
+          <p:cNvSpPr>
+            <a:spLocks noGrp="1"/>
+          </p:cNvSpPr>
+          <p:nvPr>
+            <p:ph type="ftr" sz="quarter" idx="11"/>
+          </p:nvPr>
+        </p:nvSpPr>
+        <p:spPr/>
+        <p:txBody>
+          <a:bodyPr/>
+          <a:lstStyle/>
+          <a:p>
+            <a:pPr>
+              <a:spcAft>
+                <a:spcPts val="600"/>
+              </a:spcAft>
+            </a:pPr>
+            <a:r>
+              <a:rPr lang="fr-FR" dirty="0"/>
+              <a:t>Soutenance de stage, LSPM, le 4 juillet 2024</a:t>
+            </a:r>
+          </a:p>
+        </p:txBody>
+      </p:sp>
+      <p:sp>
+        <p:nvSpPr>
+          <p:cNvPr id="5" name="Slide Number Placeholder 4">
+            <a:extLst>
+              <a:ext uri="{FF2B5EF4-FFF2-40B4-BE49-F238E27FC236}">
+                <a16:creationId xmlns:a16="http://schemas.microsoft.com/office/drawing/2014/main" id="{2712BABC-ED7D-E700-5802-278483C6EF4A}"/>
+              </a:ext>
+            </a:extLst>
+          </p:cNvPr>
+          <p:cNvSpPr>
+            <a:spLocks noGrp="1"/>
+          </p:cNvSpPr>
+          <p:nvPr>
+            <p:ph type="sldNum" sz="quarter" idx="12"/>
+          </p:nvPr>
+        </p:nvSpPr>
+        <p:spPr/>
+        <p:txBody>
+          <a:bodyPr/>
+          <a:lstStyle/>
+          <a:p>
+            <a:fld id="{BCB85A95-E1CC-4DC7-938C-5BF234670505}" type="slidenum">
+              <a:rPr lang="fr-FR" smtClean="0"/>
+              <a:pPr/>
+              <a:t>3</a:t>
+            </a:fld>
+            <a:endParaRPr lang="fr-FR"/>
+          </a:p>
+        </p:txBody>
+      </p:sp>
+    </p:spTree>
+    <p:extLst>
+      <p:ext uri="{BB962C8B-B14F-4D97-AF65-F5344CB8AC3E}">
+        <p14:creationId xmlns:p14="http://schemas.microsoft.com/office/powerpoint/2010/main" val="322109421"/>
+      </p:ext>
+    </p:extLst>
+  </p:cSld>
+  <p:clrMapOvr>
+    <a:masterClrMapping/>
+  </p:clrMapOvr>
+</p:sld>
+</file>
+
+<file path=ppt/slides/slide4.xml><?xml version="1.0" encoding="utf-8"?>
+<p:sld xmlns:a="http://schemas.openxmlformats.org/drawingml/2006/main" xmlns:r="http://schemas.openxmlformats.org/officeDocument/2006/relationships" xmlns:p="http://schemas.openxmlformats.org/presentationml/2006/main">
+  <p:cSld>
+    <p:spTree>
+      <p:nvGrpSpPr>
+        <p:cNvPr id="1" name=""/>
+        <p:cNvGrpSpPr/>
+        <p:nvPr/>
+      </p:nvGrpSpPr>
+      <p:grpSpPr>
+        <a:xfrm>
+          <a:off x="0" y="0"/>
+          <a:ext cx="0" cy="0"/>
+          <a:chOff x="0" y="0"/>
+          <a:chExt cx="0" cy="0"/>
+        </a:xfrm>
+      </p:grpSpPr>
+      <p:sp>
+        <p:nvSpPr>
+          <p:cNvPr id="2" name="Title 1">
+            <a:extLst>
+              <a:ext uri="{FF2B5EF4-FFF2-40B4-BE49-F238E27FC236}">
+                <a16:creationId xmlns:a16="http://schemas.microsoft.com/office/drawing/2014/main" id="{71AC0471-3CD4-64D2-00B9-63B5DE5F6215}"/>
+              </a:ext>
+            </a:extLst>
+          </p:cNvPr>
+          <p:cNvSpPr>
+            <a:spLocks noGrp="1"/>
+          </p:cNvSpPr>
+          <p:nvPr>
+            <p:ph type="title"/>
+          </p:nvPr>
+        </p:nvSpPr>
+        <p:spPr/>
+        <p:txBody>
+          <a:bodyPr/>
+          <a:lstStyle/>
+          <a:p>
+            <a:r>
+              <a:rPr lang="en-US" dirty="0"/>
+              <a:t>Plan de la </a:t>
+            </a:r>
+            <a:r>
+              <a:rPr lang="en-US" dirty="0" err="1"/>
+              <a:t>soutenance</a:t>
+            </a:r>
+            <a:endParaRPr lang="fr-FR" dirty="0"/>
+          </a:p>
+        </p:txBody>
+      </p:sp>
+      <p:sp>
+        <p:nvSpPr>
+          <p:cNvPr id="3" name="Content Placeholder 2">
+            <a:extLst>
+              <a:ext uri="{FF2B5EF4-FFF2-40B4-BE49-F238E27FC236}">
+                <a16:creationId xmlns:a16="http://schemas.microsoft.com/office/drawing/2014/main" id="{5865B11D-BEE2-3469-3DCD-D51FC7B29FEE}"/>
+              </a:ext>
+            </a:extLst>
+          </p:cNvPr>
+          <p:cNvSpPr>
+            <a:spLocks noGrp="1"/>
+          </p:cNvSpPr>
+          <p:nvPr>
+            <p:ph idx="1"/>
+          </p:nvPr>
+        </p:nvSpPr>
+        <p:spPr>
+          <a:xfrm>
+            <a:off x="251520" y="1269908"/>
+            <a:ext cx="5544616" cy="4856257"/>
+          </a:xfrm>
+        </p:spPr>
+        <p:txBody>
+          <a:bodyPr/>
+          <a:lstStyle/>
+          <a:p>
+            <a:pPr algn="just"/>
+            <a:r>
+              <a:rPr lang="en-US" sz="2800" dirty="0" err="1"/>
+              <a:t>Méthode</a:t>
+            </a:r>
+            <a:r>
+              <a:rPr lang="en-US" sz="2800" dirty="0"/>
+              <a:t> CRC, </a:t>
+            </a:r>
+            <a:r>
+              <a:rPr lang="en-US" sz="2800" dirty="0" err="1"/>
+              <a:t>présentation</a:t>
+            </a:r>
+            <a:r>
+              <a:rPr lang="en-US" sz="2800" dirty="0"/>
+              <a:t> de LAMMPS et OVITO, travaux de la </a:t>
+            </a:r>
+            <a:r>
+              <a:rPr lang="en-US" sz="2800" dirty="0" err="1"/>
+              <a:t>docteure</a:t>
+            </a:r>
+            <a:r>
+              <a:rPr lang="en-US" sz="2800" dirty="0"/>
+              <a:t> </a:t>
+            </a:r>
+            <a:r>
+              <a:rPr lang="en-US" sz="2800" dirty="0" err="1"/>
+              <a:t>Allouch</a:t>
+            </a:r>
+            <a:r>
+              <a:rPr lang="en-US" sz="2800" dirty="0"/>
+              <a:t> sur les clusters de Carbone</a:t>
+            </a:r>
+          </a:p>
+          <a:p>
+            <a:pPr algn="just"/>
+            <a:r>
+              <a:rPr lang="en-US" sz="2800" dirty="0" err="1"/>
+              <a:t>Présentation</a:t>
+            </a:r>
+            <a:r>
+              <a:rPr lang="en-US" sz="2800" dirty="0"/>
+              <a:t> des travaux de la </a:t>
+            </a:r>
+            <a:r>
+              <a:rPr lang="en-US" sz="2800" dirty="0" err="1"/>
+              <a:t>docteure</a:t>
+            </a:r>
+            <a:r>
+              <a:rPr lang="en-US" sz="2800" dirty="0"/>
+              <a:t> </a:t>
+            </a:r>
+            <a:r>
+              <a:rPr lang="en-US" sz="2800" dirty="0" err="1"/>
+              <a:t>Allouch</a:t>
+            </a:r>
+            <a:r>
+              <a:rPr lang="en-US" sz="2800" dirty="0"/>
+              <a:t> et des miens sur les clusters de Carbone</a:t>
+            </a:r>
+          </a:p>
+          <a:p>
+            <a:pPr algn="just"/>
+            <a:r>
+              <a:rPr lang="en-US" sz="2800" dirty="0" err="1"/>
+              <a:t>Présentation</a:t>
+            </a:r>
+            <a:r>
+              <a:rPr lang="en-US" sz="2800" dirty="0"/>
+              <a:t> des travaux sur le </a:t>
+            </a:r>
+            <a:r>
+              <a:rPr lang="en-US" sz="2800" dirty="0" err="1"/>
+              <a:t>tungstène</a:t>
+            </a:r>
+            <a:r>
+              <a:rPr lang="en-US" sz="2800" dirty="0"/>
+              <a:t> </a:t>
+            </a:r>
+          </a:p>
+        </p:txBody>
+      </p:sp>
+      <p:sp>
+        <p:nvSpPr>
+          <p:cNvPr id="4" name="Footer Placeholder 3">
+            <a:extLst>
+              <a:ext uri="{FF2B5EF4-FFF2-40B4-BE49-F238E27FC236}">
+                <a16:creationId xmlns:a16="http://schemas.microsoft.com/office/drawing/2014/main" id="{C940E716-D461-7F35-F28C-D9E17155F878}"/>
+              </a:ext>
+            </a:extLst>
+          </p:cNvPr>
+          <p:cNvSpPr>
+            <a:spLocks noGrp="1"/>
+          </p:cNvSpPr>
+          <p:nvPr>
+            <p:ph type="ftr" sz="quarter" idx="11"/>
+          </p:nvPr>
+        </p:nvSpPr>
+        <p:spPr/>
+        <p:txBody>
+          <a:bodyPr/>
+          <a:lstStyle/>
+          <a:p>
+            <a:pPr>
+              <a:spcAft>
+                <a:spcPts val="600"/>
+              </a:spcAft>
+            </a:pPr>
+            <a:r>
+              <a:rPr lang="fr-FR" dirty="0"/>
+              <a:t>Soutenance de stage, LSPM, le 4 juillet 2024</a:t>
+            </a:r>
+          </a:p>
+        </p:txBody>
+      </p:sp>
+      <p:sp>
+        <p:nvSpPr>
+          <p:cNvPr id="5" name="Slide Number Placeholder 4">
+            <a:extLst>
+              <a:ext uri="{FF2B5EF4-FFF2-40B4-BE49-F238E27FC236}">
+                <a16:creationId xmlns:a16="http://schemas.microsoft.com/office/drawing/2014/main" id="{D21618FE-AB28-D8D0-8F70-8CCDC0423476}"/>
+              </a:ext>
+            </a:extLst>
+          </p:cNvPr>
+          <p:cNvSpPr>
+            <a:spLocks noGrp="1"/>
+          </p:cNvSpPr>
+          <p:nvPr>
+            <p:ph type="sldNum" sz="quarter" idx="12"/>
+          </p:nvPr>
+        </p:nvSpPr>
+        <p:spPr/>
+        <p:txBody>
+          <a:bodyPr/>
+          <a:lstStyle/>
+          <a:p>
+            <a:fld id="{BCB85A95-E1CC-4DC7-938C-5BF234670505}" type="slidenum">
+              <a:rPr lang="fr-FR" smtClean="0"/>
+              <a:pPr/>
+              <a:t>4</a:t>
+            </a:fld>
+            <a:endParaRPr lang="fr-FR"/>
+          </a:p>
+        </p:txBody>
+      </p:sp>
+      <p:pic>
+        <p:nvPicPr>
+          <p:cNvPr id="7" name="Picture 6" descr="A BCC Tungsten crystal with blue spheres as tungsten metals.&#10;">
+            <a:extLst>
+              <a:ext uri="{FF2B5EF4-FFF2-40B4-BE49-F238E27FC236}">
+                <a16:creationId xmlns:a16="http://schemas.microsoft.com/office/drawing/2014/main" id="{A64BF9B2-E7A7-4E53-0C9C-42F75D6564EE}"/>
+              </a:ext>
+            </a:extLst>
+          </p:cNvPr>
+          <p:cNvPicPr>
+            <a:picLocks noChangeAspect="1"/>
+          </p:cNvPicPr>
+          <p:nvPr/>
+        </p:nvPicPr>
+        <p:blipFill rotWithShape="1">
+          <a:blip r:embed="rId2">
+            <a:extLst>
+              <a:ext uri="{28A0092B-C50C-407E-A947-70E740481C1C}">
+                <a14:useLocalDpi xmlns:a14="http://schemas.microsoft.com/office/drawing/2010/main" val="0"/>
+              </a:ext>
+            </a:extLst>
+          </a:blip>
+          <a:srcRect l="18588" t="12987" r="19076" b="9093"/>
+          <a:stretch/>
+        </p:blipFill>
+        <p:spPr>
+          <a:xfrm>
+            <a:off x="5796136" y="2276872"/>
+            <a:ext cx="3292637" cy="3086846"/>
+          </a:xfrm>
+          <a:prstGeom prst="rect">
+            <a:avLst/>
+          </a:prstGeom>
+        </p:spPr>
+      </p:pic>
+    </p:spTree>
+    <p:extLst>
+      <p:ext uri="{BB962C8B-B14F-4D97-AF65-F5344CB8AC3E}">
+        <p14:creationId xmlns:p14="http://schemas.microsoft.com/office/powerpoint/2010/main" val="109220022"/>
+      </p:ext>
+    </p:extLst>
+  </p:cSld>
+  <p:clrMapOvr>
+    <a:masterClrMapping/>
+  </p:clrMapOvr>
+</p:sld>
+</file>
+
+<file path=ppt/slides/slide5.xml><?xml version="1.0" encoding="utf-8"?>
+<p:sld xmlns:a="http://schemas.openxmlformats.org/drawingml/2006/main" xmlns:r="http://schemas.openxmlformats.org/officeDocument/2006/relationships" xmlns:p="http://schemas.openxmlformats.org/presentationml/2006/main">
+  <p:cSld>
+    <p:spTree>
+      <p:nvGrpSpPr>
+        <p:cNvPr id="1" name=""/>
+        <p:cNvGrpSpPr/>
+        <p:nvPr/>
+      </p:nvGrpSpPr>
+      <p:grpSpPr>
+        <a:xfrm>
+          <a:off x="0" y="0"/>
+          <a:ext cx="0" cy="0"/>
+          <a:chOff x="0" y="0"/>
+          <a:chExt cx="0" cy="0"/>
+        </a:xfrm>
+      </p:grpSpPr>
+      <p:sp>
+        <p:nvSpPr>
+          <p:cNvPr id="2" name="Title 1">
+            <a:extLst>
+              <a:ext uri="{FF2B5EF4-FFF2-40B4-BE49-F238E27FC236}">
+                <a16:creationId xmlns:a16="http://schemas.microsoft.com/office/drawing/2014/main" id="{1037E3EA-F390-7CC0-EC9A-1D6333C156E2}"/>
+              </a:ext>
+            </a:extLst>
+          </p:cNvPr>
+          <p:cNvSpPr>
+            <a:spLocks noGrp="1"/>
+          </p:cNvSpPr>
+          <p:nvPr>
+            <p:ph type="title"/>
+          </p:nvPr>
+        </p:nvSpPr>
+        <p:spPr/>
+        <p:txBody>
+          <a:bodyPr/>
+          <a:lstStyle/>
+          <a:p>
+            <a:r>
+              <a:rPr lang="en-US" sz="2800" dirty="0"/>
+              <a:t>Interactions </a:t>
+            </a:r>
+            <a:r>
+              <a:rPr lang="en-US" sz="2800" dirty="0" err="1"/>
+              <a:t>atomiques</a:t>
+            </a:r>
+            <a:r>
+              <a:rPr lang="en-US" sz="2800" dirty="0"/>
+              <a:t> et </a:t>
+            </a:r>
+            <a:r>
+              <a:rPr lang="en-US" sz="2800" dirty="0" err="1"/>
+              <a:t>termes</a:t>
+            </a:r>
+            <a:r>
+              <a:rPr lang="en-US" sz="2800" dirty="0"/>
+              <a:t> du </a:t>
+            </a:r>
+            <a:r>
+              <a:rPr lang="en-US" sz="2800" dirty="0" err="1"/>
+              <a:t>potentiel</a:t>
+            </a:r>
+            <a:endParaRPr lang="fr-FR" sz="2800" dirty="0"/>
+          </a:p>
+        </p:txBody>
+      </p:sp>
+      <p:pic>
+        <p:nvPicPr>
+          <p:cNvPr id="7" name="Content Placeholder 6">
+            <a:extLst>
+              <a:ext uri="{FF2B5EF4-FFF2-40B4-BE49-F238E27FC236}">
+                <a16:creationId xmlns:a16="http://schemas.microsoft.com/office/drawing/2014/main" id="{0CCBEBC0-BA03-EDD2-6384-6E032FBA62B1}"/>
+              </a:ext>
+            </a:extLst>
+          </p:cNvPr>
+          <p:cNvPicPr>
+            <a:picLocks noGrp="1" noChangeAspect="1"/>
+          </p:cNvPicPr>
+          <p:nvPr>
+            <p:ph idx="1"/>
+          </p:nvPr>
+        </p:nvPicPr>
+        <p:blipFill rotWithShape="1">
+          <a:blip r:embed="rId2"/>
+          <a:srcRect l="10691" t="5776" r="10463"/>
+          <a:stretch/>
+        </p:blipFill>
+        <p:spPr>
+          <a:xfrm>
+            <a:off x="3707903" y="1268760"/>
+            <a:ext cx="5088565" cy="4464496"/>
+          </a:xfrm>
+        </p:spPr>
+      </p:pic>
+      <p:sp>
+        <p:nvSpPr>
+          <p:cNvPr id="4" name="Footer Placeholder 3">
+            <a:extLst>
+              <a:ext uri="{FF2B5EF4-FFF2-40B4-BE49-F238E27FC236}">
+                <a16:creationId xmlns:a16="http://schemas.microsoft.com/office/drawing/2014/main" id="{ECB9C905-34A5-BCB6-7FE2-EC832EB94F1C}"/>
+              </a:ext>
+            </a:extLst>
+          </p:cNvPr>
+          <p:cNvSpPr>
+            <a:spLocks noGrp="1"/>
+          </p:cNvSpPr>
+          <p:nvPr>
+            <p:ph type="ftr" sz="quarter" idx="11"/>
+          </p:nvPr>
+        </p:nvSpPr>
+        <p:spPr/>
+        <p:txBody>
+          <a:bodyPr/>
+          <a:lstStyle/>
+          <a:p>
+            <a:pPr>
+              <a:spcAft>
+                <a:spcPts val="600"/>
+              </a:spcAft>
+            </a:pPr>
+            <a:r>
+              <a:rPr lang="fr-FR" dirty="0"/>
+              <a:t>Soutenance de stage, LSPM, le 4 juillet 2024</a:t>
+            </a:r>
+          </a:p>
+        </p:txBody>
+      </p:sp>
+      <p:sp>
+        <p:nvSpPr>
+          <p:cNvPr id="5" name="Slide Number Placeholder 4">
+            <a:extLst>
+              <a:ext uri="{FF2B5EF4-FFF2-40B4-BE49-F238E27FC236}">
+                <a16:creationId xmlns:a16="http://schemas.microsoft.com/office/drawing/2014/main" id="{75A72F7D-CA3B-0FC7-27A4-18364B13A711}"/>
+              </a:ext>
+            </a:extLst>
+          </p:cNvPr>
+          <p:cNvSpPr>
+            <a:spLocks noGrp="1"/>
+          </p:cNvSpPr>
+          <p:nvPr>
+            <p:ph type="sldNum" sz="quarter" idx="12"/>
+          </p:nvPr>
+        </p:nvSpPr>
+        <p:spPr/>
+        <p:txBody>
+          <a:bodyPr/>
+          <a:lstStyle/>
+          <a:p>
+            <a:fld id="{BCB85A95-E1CC-4DC7-938C-5BF234670505}" type="slidenum">
+              <a:rPr lang="fr-FR" smtClean="0"/>
+              <a:pPr/>
+              <a:t>5</a:t>
+            </a:fld>
+            <a:endParaRPr lang="fr-FR"/>
+          </a:p>
+        </p:txBody>
+      </p:sp>
+      <p:sp>
+        <p:nvSpPr>
+          <p:cNvPr id="8" name="TextBox 7">
+            <a:extLst>
+              <a:ext uri="{FF2B5EF4-FFF2-40B4-BE49-F238E27FC236}">
+                <a16:creationId xmlns:a16="http://schemas.microsoft.com/office/drawing/2014/main" id="{7FE563D7-B26B-4612-AC82-F01C7285E387}"/>
+              </a:ext>
+            </a:extLst>
+          </p:cNvPr>
+          <p:cNvSpPr txBox="1"/>
+          <p:nvPr/>
+        </p:nvSpPr>
+        <p:spPr>
+          <a:xfrm>
+            <a:off x="320112" y="1484784"/>
+            <a:ext cx="3384375" cy="1754326"/>
+          </a:xfrm>
+          <a:prstGeom prst="rect">
+            <a:avLst/>
+          </a:prstGeom>
+          <a:noFill/>
+        </p:spPr>
+        <p:txBody>
+          <a:bodyPr wrap="square" rtlCol="0">
+            <a:spAutoFit/>
+          </a:bodyPr>
+          <a:lstStyle/>
+          <a:p>
+            <a:r>
+              <a:rPr lang="en-US" b="1" dirty="0" err="1"/>
+              <a:t>Potentiels</a:t>
+            </a:r>
+            <a:r>
+              <a:rPr lang="en-US" b="1" dirty="0"/>
+              <a:t> </a:t>
+            </a:r>
+            <a:r>
+              <a:rPr lang="en-US" b="1" dirty="0" err="1"/>
+              <a:t>d’ordre</a:t>
+            </a:r>
+            <a:r>
+              <a:rPr lang="en-US" b="1" dirty="0"/>
+              <a:t> de liaison</a:t>
+            </a:r>
+          </a:p>
+          <a:p>
+            <a:pPr marL="285750" indent="-285750">
+              <a:buFont typeface="Arial" panose="020B0604020202020204" pitchFamily="34" charset="0"/>
+              <a:buChar char="•"/>
+            </a:pPr>
+            <a:r>
+              <a:rPr lang="fr-FR" dirty="0"/>
+              <a:t>Interaction de paire</a:t>
+            </a:r>
+          </a:p>
+          <a:p>
+            <a:pPr marL="285750" indent="-285750">
+              <a:buFont typeface="Arial" panose="020B0604020202020204" pitchFamily="34" charset="0"/>
+              <a:buChar char="•"/>
+            </a:pPr>
+            <a:r>
+              <a:rPr lang="fr-FR" dirty="0"/>
+              <a:t>Energie de torsion</a:t>
+            </a:r>
+          </a:p>
+          <a:p>
+            <a:pPr marL="285750" indent="-285750">
+              <a:buFont typeface="Arial" panose="020B0604020202020204" pitchFamily="34" charset="0"/>
+              <a:buChar char="•"/>
+            </a:pPr>
+            <a:r>
+              <a:rPr lang="fr-FR" dirty="0"/>
+              <a:t>Ordre de liaison</a:t>
+            </a:r>
+          </a:p>
+          <a:p>
+            <a:pPr marL="285750" indent="-285750">
+              <a:buFont typeface="Arial" panose="020B0604020202020204" pitchFamily="34" charset="0"/>
+              <a:buChar char="•"/>
+            </a:pPr>
+            <a:r>
+              <a:rPr lang="en-US" dirty="0" err="1"/>
+              <a:t>Énergie</a:t>
+            </a:r>
+            <a:r>
+              <a:rPr lang="en-US" dirty="0"/>
+              <a:t> de rotation</a:t>
+            </a:r>
+          </a:p>
+          <a:p>
+            <a:pPr marL="285750" indent="-285750">
+              <a:buFont typeface="Arial" panose="020B0604020202020204" pitchFamily="34" charset="0"/>
+              <a:buChar char="•"/>
+            </a:pPr>
+            <a:r>
+              <a:rPr lang="en-US" dirty="0"/>
+              <a:t>Angle de liaison</a:t>
+            </a:r>
+          </a:p>
+        </p:txBody>
+      </p:sp>
+    </p:spTree>
+    <p:extLst>
+      <p:ext uri="{BB962C8B-B14F-4D97-AF65-F5344CB8AC3E}">
+        <p14:creationId xmlns:p14="http://schemas.microsoft.com/office/powerpoint/2010/main" val="1828115190"/>
+      </p:ext>
+    </p:extLst>
+  </p:cSld>
+  <p:clrMapOvr>
+    <a:masterClrMapping/>
+  </p:clrMapOvr>
+</p:sld>
+</file>
+
+<file path=ppt/slides/slide6.xml><?xml version="1.0" encoding="utf-8"?>
+<p:sld xmlns:a="http://schemas.openxmlformats.org/drawingml/2006/main" xmlns:r="http://schemas.openxmlformats.org/officeDocument/2006/relationships" xmlns:p="http://schemas.openxmlformats.org/presentationml/2006/main">
+  <p:cSld>
+    <p:spTree>
+      <p:nvGrpSpPr>
+        <p:cNvPr id="1" name=""/>
+        <p:cNvGrpSpPr/>
+        <p:nvPr/>
+      </p:nvGrpSpPr>
+      <p:grpSpPr>
+        <a:xfrm>
+          <a:off x="0" y="0"/>
+          <a:ext cx="0" cy="0"/>
+          <a:chOff x="0" y="0"/>
+          <a:chExt cx="0" cy="0"/>
+        </a:xfrm>
+      </p:grpSpPr>
+      <p:sp>
+        <p:nvSpPr>
+          <p:cNvPr id="2" name="Title 1">
+            <a:extLst>
+              <a:ext uri="{FF2B5EF4-FFF2-40B4-BE49-F238E27FC236}">
+                <a16:creationId xmlns:a16="http://schemas.microsoft.com/office/drawing/2014/main" id="{C494B012-AC1A-4071-0820-780A5C1FFC0D}"/>
+              </a:ext>
+            </a:extLst>
+          </p:cNvPr>
+          <p:cNvSpPr>
+            <a:spLocks noGrp="1"/>
+          </p:cNvSpPr>
+          <p:nvPr>
+            <p:ph type="title"/>
+          </p:nvPr>
+        </p:nvSpPr>
+        <p:spPr>
+          <a:xfrm>
+            <a:off x="323528" y="188640"/>
+            <a:ext cx="8566720" cy="792088"/>
+          </a:xfrm>
+        </p:spPr>
+        <p:txBody>
+          <a:bodyPr wrap="square" anchor="b">
+            <a:noAutofit/>
+          </a:bodyPr>
+          <a:lstStyle/>
+          <a:p>
+            <a:pPr>
+              <a:lnSpc>
+                <a:spcPct val="90000"/>
+              </a:lnSpc>
+            </a:pPr>
+            <a:r>
+              <a:rPr lang="en-US" sz="3200" dirty="0"/>
+              <a:t>Condensation et </a:t>
+            </a:r>
+            <a:r>
+              <a:rPr lang="en-US" sz="3200" dirty="0" err="1"/>
+              <a:t>Recuit</a:t>
+            </a:r>
+            <a:r>
+              <a:rPr lang="en-US" sz="3200" dirty="0"/>
+              <a:t> </a:t>
+            </a:r>
+            <a:r>
+              <a:rPr lang="en-US" sz="3200" dirty="0" err="1"/>
+              <a:t>Combinés</a:t>
+            </a:r>
+            <a:r>
+              <a:rPr lang="en-US" sz="3200" dirty="0"/>
+              <a:t> (CRC)</a:t>
+            </a:r>
+            <a:endParaRPr lang="fr-FR" sz="3200" dirty="0"/>
+          </a:p>
+        </p:txBody>
+      </p:sp>
+      <p:pic>
+        <p:nvPicPr>
+          <p:cNvPr id="7" name="Content Placeholder 6">
+            <a:extLst>
+              <a:ext uri="{FF2B5EF4-FFF2-40B4-BE49-F238E27FC236}">
+                <a16:creationId xmlns:a16="http://schemas.microsoft.com/office/drawing/2014/main" id="{EE0D2895-EC08-5621-6B8C-EA49B3AF994A}"/>
+              </a:ext>
+            </a:extLst>
+          </p:cNvPr>
+          <p:cNvPicPr>
+            <a:picLocks noGrp="1" noChangeAspect="1"/>
+          </p:cNvPicPr>
+          <p:nvPr>
+            <p:ph idx="1"/>
+          </p:nvPr>
+        </p:nvPicPr>
+        <p:blipFill rotWithShape="1">
+          <a:blip r:embed="rId2"/>
+          <a:stretch/>
+        </p:blipFill>
+        <p:spPr>
+          <a:xfrm>
+            <a:off x="440248" y="1988840"/>
+            <a:ext cx="8208913" cy="4020652"/>
+          </a:xfrm>
+          <a:noFill/>
+        </p:spPr>
+      </p:pic>
+      <p:sp>
+        <p:nvSpPr>
+          <p:cNvPr id="4" name="Footer Placeholder 3">
+            <a:extLst>
+              <a:ext uri="{FF2B5EF4-FFF2-40B4-BE49-F238E27FC236}">
+                <a16:creationId xmlns:a16="http://schemas.microsoft.com/office/drawing/2014/main" id="{C16A53FA-5269-C5C9-41B0-B9137B9FA7C5}"/>
+              </a:ext>
+            </a:extLst>
+          </p:cNvPr>
+          <p:cNvSpPr>
+            <a:spLocks noGrp="1"/>
+          </p:cNvSpPr>
+          <p:nvPr>
+            <p:ph type="ftr" sz="quarter" idx="11"/>
+          </p:nvPr>
+        </p:nvSpPr>
+        <p:spPr>
+          <a:xfrm>
+            <a:off x="2627784" y="6356350"/>
+            <a:ext cx="5400600" cy="365125"/>
+          </a:xfrm>
+        </p:spPr>
+        <p:txBody>
+          <a:bodyPr anchor="ctr">
+            <a:normAutofit/>
+          </a:bodyPr>
+          <a:lstStyle/>
+          <a:p>
+            <a:pPr>
+              <a:spcAft>
+                <a:spcPts val="600"/>
+              </a:spcAft>
+            </a:pPr>
+            <a:r>
+              <a:rPr lang="fr-FR" dirty="0"/>
+              <a:t>Soutenance de stage, LSPM, le 4 juillet 2024</a:t>
+            </a:r>
+          </a:p>
+        </p:txBody>
+      </p:sp>
+      <p:sp>
+        <p:nvSpPr>
+          <p:cNvPr id="5" name="Slide Number Placeholder 4">
+            <a:extLst>
+              <a:ext uri="{FF2B5EF4-FFF2-40B4-BE49-F238E27FC236}">
+                <a16:creationId xmlns:a16="http://schemas.microsoft.com/office/drawing/2014/main" id="{77433B99-7D7E-6089-AD71-C965E07E0990}"/>
+              </a:ext>
+            </a:extLst>
+          </p:cNvPr>
+          <p:cNvSpPr>
+            <a:spLocks noGrp="1"/>
+          </p:cNvSpPr>
+          <p:nvPr>
+            <p:ph type="sldNum" sz="quarter" idx="12"/>
+          </p:nvPr>
+        </p:nvSpPr>
+        <p:spPr>
+          <a:xfrm>
+            <a:off x="8172400" y="6343334"/>
+            <a:ext cx="717848" cy="378141"/>
+          </a:xfrm>
+        </p:spPr>
+        <p:txBody>
+          <a:bodyPr anchor="ctr">
+            <a:normAutofit/>
+          </a:bodyPr>
+          <a:lstStyle/>
+          <a:p>
+            <a:pPr>
+              <a:spcAft>
+                <a:spcPts val="600"/>
+              </a:spcAft>
+            </a:pPr>
+            <a:fld id="{BCB85A95-E1CC-4DC7-938C-5BF234670505}" type="slidenum">
+              <a:rPr lang="fr-FR" smtClean="0"/>
+              <a:pPr>
+                <a:spcAft>
+                  <a:spcPts val="600"/>
+                </a:spcAft>
+              </a:pPr>
+              <a:t>6</a:t>
+            </a:fld>
+            <a:endParaRPr lang="fr-FR"/>
+          </a:p>
+        </p:txBody>
+      </p:sp>
+      <p:sp>
+        <p:nvSpPr>
+          <p:cNvPr id="8" name="TextBox 7">
+            <a:extLst>
+              <a:ext uri="{FF2B5EF4-FFF2-40B4-BE49-F238E27FC236}">
+                <a16:creationId xmlns:a16="http://schemas.microsoft.com/office/drawing/2014/main" id="{6770ACF6-3C54-F5B9-5BEB-EB66FA4298C6}"/>
+              </a:ext>
+            </a:extLst>
+          </p:cNvPr>
+          <p:cNvSpPr txBox="1"/>
+          <p:nvPr/>
+        </p:nvSpPr>
+        <p:spPr>
+          <a:xfrm>
+            <a:off x="747876" y="1331205"/>
+            <a:ext cx="7648248" cy="369332"/>
+          </a:xfrm>
+          <a:prstGeom prst="rect">
+            <a:avLst/>
+          </a:prstGeom>
+          <a:noFill/>
+        </p:spPr>
+        <p:txBody>
+          <a:bodyPr wrap="none" rtlCol="0">
+            <a:spAutoFit/>
+          </a:bodyPr>
+          <a:lstStyle/>
+          <a:p>
+            <a:r>
+              <a:rPr lang="en-US" dirty="0"/>
+              <a:t>Diagramme </a:t>
+            </a:r>
+            <a:r>
+              <a:rPr lang="en-US" dirty="0" err="1"/>
+              <a:t>représentatif</a:t>
+            </a:r>
+            <a:r>
+              <a:rPr lang="en-US" dirty="0"/>
+              <a:t> des 3 étapes </a:t>
+            </a:r>
+            <a:r>
+              <a:rPr lang="en-US" dirty="0" err="1"/>
+              <a:t>essentielles</a:t>
+            </a:r>
+            <a:r>
+              <a:rPr lang="en-US" dirty="0"/>
+              <a:t> de la </a:t>
+            </a:r>
+            <a:r>
+              <a:rPr lang="en-US" dirty="0" err="1"/>
+              <a:t>méthode</a:t>
+            </a:r>
+            <a:r>
+              <a:rPr lang="en-US" dirty="0"/>
+              <a:t> CRC</a:t>
+            </a:r>
+            <a:endParaRPr lang="fr-FR" dirty="0"/>
+          </a:p>
+        </p:txBody>
+      </p:sp>
+    </p:spTree>
+    <p:extLst>
+      <p:ext uri="{BB962C8B-B14F-4D97-AF65-F5344CB8AC3E}">
+        <p14:creationId xmlns:p14="http://schemas.microsoft.com/office/powerpoint/2010/main" val="1917460874"/>
+      </p:ext>
+    </p:extLst>
+  </p:cSld>
+  <p:clrMapOvr>
+    <a:masterClrMapping/>
+  </p:clrMapOvr>
+</p:sld>
+</file>
+
+<file path=ppt/slides/slide7.xml><?xml version="1.0" encoding="utf-8"?>
+<p:sld xmlns:a="http://schemas.openxmlformats.org/drawingml/2006/main" xmlns:r="http://schemas.openxmlformats.org/officeDocument/2006/relationships" xmlns:p="http://schemas.openxmlformats.org/presentationml/2006/main">
+  <p:cSld>
+    <p:spTree>
+      <p:nvGrpSpPr>
+        <p:cNvPr id="1" name=""/>
+        <p:cNvGrpSpPr/>
+        <p:nvPr/>
+      </p:nvGrpSpPr>
+      <p:grpSpPr>
+        <a:xfrm>
+          <a:off x="0" y="0"/>
+          <a:ext cx="0" cy="0"/>
+          <a:chOff x="0" y="0"/>
+          <a:chExt cx="0" cy="0"/>
+        </a:xfrm>
+      </p:grpSpPr>
+      <p:sp>
+        <p:nvSpPr>
+          <p:cNvPr id="12" name="Title 1">
+            <a:extLst>
+              <a:ext uri="{FF2B5EF4-FFF2-40B4-BE49-F238E27FC236}">
+                <a16:creationId xmlns:a16="http://schemas.microsoft.com/office/drawing/2014/main" id="{E2E2CF7D-D63E-4173-9D06-36BE825A2592}"/>
+              </a:ext>
+            </a:extLst>
+          </p:cNvPr>
+          <p:cNvSpPr>
+            <a:spLocks noGrp="1"/>
+          </p:cNvSpPr>
+          <p:nvPr>
+            <p:ph type="title"/>
+          </p:nvPr>
+        </p:nvSpPr>
+        <p:spPr>
+          <a:xfrm>
+            <a:off x="323528" y="188640"/>
+            <a:ext cx="8568952" cy="792088"/>
+          </a:xfrm>
+        </p:spPr>
+        <p:txBody>
+          <a:bodyPr/>
+          <a:lstStyle/>
+          <a:p>
+            <a:r>
+              <a:rPr lang="en-US" dirty="0" err="1"/>
+              <a:t>Logiciels</a:t>
+            </a:r>
+            <a:r>
+              <a:rPr lang="en-US" dirty="0"/>
+              <a:t> </a:t>
+            </a:r>
+            <a:r>
+              <a:rPr lang="en-US" dirty="0" err="1"/>
+              <a:t>utilisés</a:t>
+            </a:r>
+            <a:r>
+              <a:rPr lang="en-US" dirty="0"/>
+              <a:t> </a:t>
+            </a:r>
+          </a:p>
+        </p:txBody>
+      </p:sp>
+      <p:pic>
+        <p:nvPicPr>
+          <p:cNvPr id="7" name="Picture 6" descr="A green ball on a black background&#10;&#10;Description automatically generated">
+            <a:extLst>
+              <a:ext uri="{FF2B5EF4-FFF2-40B4-BE49-F238E27FC236}">
+                <a16:creationId xmlns:a16="http://schemas.microsoft.com/office/drawing/2014/main" id="{D513E00E-B1B9-B8A7-BED4-6393501516F8}"/>
+              </a:ext>
+            </a:extLst>
+          </p:cNvPr>
+          <p:cNvPicPr>
+            <a:picLocks noChangeAspect="1"/>
+          </p:cNvPicPr>
+          <p:nvPr/>
+        </p:nvPicPr>
+        <p:blipFill>
+          <a:blip r:embed="rId2" cstate="print">
+            <a:extLst>
+              <a:ext uri="{28A0092B-C50C-407E-A947-70E740481C1C}">
+                <a14:useLocalDpi xmlns:a14="http://schemas.microsoft.com/office/drawing/2010/main" val="0"/>
+              </a:ext>
+            </a:extLst>
+          </a:blip>
+          <a:stretch>
+            <a:fillRect/>
+          </a:stretch>
+        </p:blipFill>
+        <p:spPr>
+          <a:xfrm>
+            <a:off x="251520" y="1412776"/>
+            <a:ext cx="4244280" cy="1634047"/>
+          </a:xfrm>
+          <a:prstGeom prst="rect">
+            <a:avLst/>
+          </a:prstGeom>
+          <a:noFill/>
+        </p:spPr>
+      </p:pic>
+      <p:pic>
+        <p:nvPicPr>
+          <p:cNvPr id="9" name="Content Placeholder 8" descr="A blue and yellow dots&#10;&#10;Description automatically generated">
+            <a:extLst>
+              <a:ext uri="{FF2B5EF4-FFF2-40B4-BE49-F238E27FC236}">
+                <a16:creationId xmlns:a16="http://schemas.microsoft.com/office/drawing/2014/main" id="{3C8D82F0-976A-5BE6-36E9-4AA02911FF74}"/>
+              </a:ext>
+            </a:extLst>
+          </p:cNvPr>
+          <p:cNvPicPr>
+            <a:picLocks noGrp="1" noChangeAspect="1"/>
+          </p:cNvPicPr>
+          <p:nvPr>
+            <p:ph sz="half" idx="2"/>
+          </p:nvPr>
+        </p:nvPicPr>
+        <p:blipFill>
+          <a:blip r:embed="rId3">
+            <a:extLst>
+              <a:ext uri="{28A0092B-C50C-407E-A947-70E740481C1C}">
+                <a14:useLocalDpi xmlns:a14="http://schemas.microsoft.com/office/drawing/2010/main" val="0"/>
+              </a:ext>
+            </a:extLst>
+          </a:blip>
+          <a:stretch>
+            <a:fillRect/>
+          </a:stretch>
+        </p:blipFill>
+        <p:spPr>
+          <a:xfrm>
+            <a:off x="4941887" y="1642120"/>
+            <a:ext cx="3657600" cy="1066800"/>
+          </a:xfrm>
+        </p:spPr>
+      </p:pic>
+      <p:sp>
+        <p:nvSpPr>
+          <p:cNvPr id="4" name="Footer Placeholder 3">
+            <a:extLst>
+              <a:ext uri="{FF2B5EF4-FFF2-40B4-BE49-F238E27FC236}">
+                <a16:creationId xmlns:a16="http://schemas.microsoft.com/office/drawing/2014/main" id="{6CD25AC5-CA38-7A2F-292E-5EE2413A9950}"/>
+              </a:ext>
+            </a:extLst>
+          </p:cNvPr>
+          <p:cNvSpPr>
+            <a:spLocks noGrp="1"/>
+          </p:cNvSpPr>
+          <p:nvPr>
+            <p:ph type="ftr" sz="quarter" idx="11"/>
+          </p:nvPr>
+        </p:nvSpPr>
+        <p:spPr>
+          <a:xfrm>
+            <a:off x="2627784" y="6356350"/>
+            <a:ext cx="5400600" cy="365125"/>
+          </a:xfrm>
+        </p:spPr>
+        <p:txBody>
+          <a:bodyPr anchor="ctr">
+            <a:normAutofit/>
+          </a:bodyPr>
+          <a:lstStyle/>
+          <a:p>
+            <a:pPr>
+              <a:spcAft>
+                <a:spcPts val="600"/>
+              </a:spcAft>
+            </a:pPr>
+            <a:r>
+              <a:rPr lang="fr-FR"/>
+              <a:t>CONFERENCE - Ville, Pays - Date</a:t>
+            </a:r>
+          </a:p>
+        </p:txBody>
+      </p:sp>
+      <p:sp>
+        <p:nvSpPr>
+          <p:cNvPr id="5" name="Slide Number Placeholder 4">
+            <a:extLst>
+              <a:ext uri="{FF2B5EF4-FFF2-40B4-BE49-F238E27FC236}">
+                <a16:creationId xmlns:a16="http://schemas.microsoft.com/office/drawing/2014/main" id="{0A2F392F-0AF0-0314-7BEE-810599A18E75}"/>
+              </a:ext>
+            </a:extLst>
+          </p:cNvPr>
+          <p:cNvSpPr>
+            <a:spLocks noGrp="1"/>
+          </p:cNvSpPr>
+          <p:nvPr>
+            <p:ph type="sldNum" sz="quarter" idx="12"/>
+          </p:nvPr>
+        </p:nvSpPr>
+        <p:spPr>
+          <a:xfrm>
+            <a:off x="8172400" y="6356350"/>
+            <a:ext cx="717848" cy="365125"/>
+          </a:xfrm>
+        </p:spPr>
+        <p:txBody>
+          <a:bodyPr anchor="ctr">
+            <a:normAutofit/>
+          </a:bodyPr>
+          <a:lstStyle/>
+          <a:p>
+            <a:pPr>
+              <a:spcAft>
+                <a:spcPts val="600"/>
+              </a:spcAft>
+            </a:pPr>
+            <a:fld id="{BCB85A95-E1CC-4DC7-938C-5BF234670505}" type="slidenum">
+              <a:rPr lang="fr-FR" smtClean="0"/>
+              <a:pPr>
+                <a:spcAft>
+                  <a:spcPts val="600"/>
+                </a:spcAft>
+              </a:pPr>
+              <a:t>7</a:t>
+            </a:fld>
+            <a:endParaRPr lang="fr-FR"/>
+          </a:p>
+        </p:txBody>
+      </p:sp>
+      <p:sp>
+        <p:nvSpPr>
+          <p:cNvPr id="11" name="TextBox 10">
+            <a:extLst>
+              <a:ext uri="{FF2B5EF4-FFF2-40B4-BE49-F238E27FC236}">
+                <a16:creationId xmlns:a16="http://schemas.microsoft.com/office/drawing/2014/main" id="{4C0CB515-5BF1-980E-7F92-F847FDFDCEB1}"/>
+              </a:ext>
+            </a:extLst>
+          </p:cNvPr>
+          <p:cNvSpPr txBox="1"/>
+          <p:nvPr/>
+        </p:nvSpPr>
+        <p:spPr>
+          <a:xfrm>
+            <a:off x="467544" y="3429000"/>
+            <a:ext cx="4104456" cy="2031325"/>
+          </a:xfrm>
+          <a:prstGeom prst="rect">
+            <a:avLst/>
+          </a:prstGeom>
+        </p:spPr>
+        <p:style>
+          <a:lnRef idx="2">
+            <a:schemeClr val="dk1"/>
+          </a:lnRef>
+          <a:fillRef idx="1">
+            <a:schemeClr val="lt1"/>
+          </a:fillRef>
+          <a:effectRef idx="0">
+            <a:schemeClr val="dk1"/>
+          </a:effectRef>
+          <a:fontRef idx="minor">
+            <a:schemeClr val="dk1"/>
+          </a:fontRef>
+        </p:style>
+        <p:txBody>
+          <a:bodyPr wrap="square" rtlCol="0">
+            <a:spAutoFit/>
+          </a:bodyPr>
+          <a:lstStyle/>
+          <a:p>
+            <a:r>
+              <a:rPr lang="fr-FR" dirty="0">
+                <a:latin typeface="Times New Roman" panose="02020603050405020304" pitchFamily="18" charset="0"/>
+                <a:cs typeface="Times New Roman" panose="02020603050405020304" pitchFamily="18" charset="0"/>
+              </a:rPr>
+              <a:t>OVITO, ou Open </a:t>
+            </a:r>
+            <a:r>
+              <a:rPr lang="fr-FR" dirty="0" err="1">
+                <a:latin typeface="Times New Roman" panose="02020603050405020304" pitchFamily="18" charset="0"/>
+                <a:cs typeface="Times New Roman" panose="02020603050405020304" pitchFamily="18" charset="0"/>
+              </a:rPr>
+              <a:t>Visualization</a:t>
+            </a:r>
+            <a:r>
+              <a:rPr lang="fr-FR" dirty="0">
+                <a:latin typeface="Times New Roman" panose="02020603050405020304" pitchFamily="18" charset="0"/>
+                <a:cs typeface="Times New Roman" panose="02020603050405020304" pitchFamily="18" charset="0"/>
+              </a:rPr>
+              <a:t> Tool, est un logiciel de visualisation et d'analyse scientifique</a:t>
+            </a:r>
+          </a:p>
+          <a:p>
+            <a:pPr marL="285750" indent="-285750">
+              <a:buFont typeface="Arial" panose="020B0604020202020204" pitchFamily="34" charset="0"/>
+              <a:buChar char="•"/>
+            </a:pPr>
+            <a:r>
+              <a:rPr lang="fr-FR" dirty="0">
+                <a:latin typeface="Times New Roman" panose="02020603050405020304" pitchFamily="18" charset="0"/>
+                <a:cs typeface="Times New Roman" panose="02020603050405020304" pitchFamily="18" charset="0"/>
+              </a:rPr>
+              <a:t>Visualisation</a:t>
+            </a:r>
+          </a:p>
+          <a:p>
+            <a:pPr marL="285750" indent="-285750">
+              <a:buFont typeface="Arial" panose="020B0604020202020204" pitchFamily="34" charset="0"/>
+              <a:buChar char="•"/>
+            </a:pPr>
+            <a:r>
+              <a:rPr lang="fr-FR" dirty="0">
+                <a:latin typeface="Times New Roman" panose="02020603050405020304" pitchFamily="18" charset="0"/>
+                <a:cs typeface="Times New Roman" panose="02020603050405020304" pitchFamily="18" charset="0"/>
+              </a:rPr>
+              <a:t>Analyse</a:t>
+            </a:r>
+          </a:p>
+          <a:p>
+            <a:pPr marL="285750" indent="-285750">
+              <a:buFont typeface="Arial" panose="020B0604020202020204" pitchFamily="34" charset="0"/>
+              <a:buChar char="•"/>
+            </a:pPr>
+            <a:r>
+              <a:rPr lang="fr-FR" dirty="0">
+                <a:latin typeface="Times New Roman" panose="02020603050405020304" pitchFamily="18" charset="0"/>
+                <a:cs typeface="Times New Roman" panose="02020603050405020304" pitchFamily="18" charset="0"/>
+              </a:rPr>
+              <a:t>Personnalisation </a:t>
+            </a:r>
+          </a:p>
+          <a:p>
+            <a:pPr marL="285750" indent="-285750">
+              <a:buFont typeface="Arial" panose="020B0604020202020204" pitchFamily="34" charset="0"/>
+              <a:buChar char="•"/>
+            </a:pPr>
+            <a:r>
+              <a:rPr lang="fr-FR" dirty="0">
+                <a:latin typeface="Times New Roman" panose="02020603050405020304" pitchFamily="18" charset="0"/>
+                <a:cs typeface="Times New Roman" panose="02020603050405020304" pitchFamily="18" charset="0"/>
+              </a:rPr>
+              <a:t>Exportation</a:t>
+            </a:r>
+          </a:p>
+        </p:txBody>
+      </p:sp>
+      <p:sp>
+        <p:nvSpPr>
+          <p:cNvPr id="16" name="TextBox 15">
+            <a:extLst>
+              <a:ext uri="{FF2B5EF4-FFF2-40B4-BE49-F238E27FC236}">
+                <a16:creationId xmlns:a16="http://schemas.microsoft.com/office/drawing/2014/main" id="{4E47BFD6-DE63-FC57-AAAD-EDC80041038C}"/>
+              </a:ext>
+            </a:extLst>
+          </p:cNvPr>
+          <p:cNvSpPr txBox="1"/>
+          <p:nvPr/>
+        </p:nvSpPr>
+        <p:spPr>
+          <a:xfrm>
+            <a:off x="4716016" y="3429000"/>
+            <a:ext cx="3960440" cy="1477328"/>
+          </a:xfrm>
+          <a:prstGeom prst="rect">
+            <a:avLst/>
+          </a:prstGeom>
+        </p:spPr>
+        <p:style>
+          <a:lnRef idx="2">
+            <a:schemeClr val="dk1"/>
+          </a:lnRef>
+          <a:fillRef idx="1">
+            <a:schemeClr val="lt1"/>
+          </a:fillRef>
+          <a:effectRef idx="0">
+            <a:schemeClr val="dk1"/>
+          </a:effectRef>
+          <a:fontRef idx="minor">
+            <a:schemeClr val="dk1"/>
+          </a:fontRef>
+        </p:style>
+        <p:txBody>
+          <a:bodyPr wrap="square" rtlCol="0">
+            <a:spAutoFit/>
+          </a:bodyPr>
+          <a:lstStyle/>
+          <a:p>
+            <a:r>
+              <a:rPr lang="fr-FR" dirty="0">
+                <a:latin typeface="Times New Roman" panose="02020603050405020304" pitchFamily="18" charset="0"/>
+                <a:cs typeface="Times New Roman" panose="02020603050405020304" pitchFamily="18" charset="0"/>
+              </a:rPr>
+              <a:t>LAMMPS (Large-</a:t>
+            </a:r>
+            <a:r>
+              <a:rPr lang="fr-FR" dirty="0" err="1">
+                <a:latin typeface="Times New Roman" panose="02020603050405020304" pitchFamily="18" charset="0"/>
+                <a:cs typeface="Times New Roman" panose="02020603050405020304" pitchFamily="18" charset="0"/>
+              </a:rPr>
+              <a:t>scale</a:t>
+            </a:r>
+            <a:r>
+              <a:rPr lang="fr-FR" dirty="0">
+                <a:latin typeface="Times New Roman" panose="02020603050405020304" pitchFamily="18" charset="0"/>
+                <a:cs typeface="Times New Roman" panose="02020603050405020304" pitchFamily="18" charset="0"/>
+              </a:rPr>
+              <a:t> Atomic / </a:t>
+            </a:r>
+            <a:r>
+              <a:rPr lang="fr-FR" dirty="0" err="1">
+                <a:latin typeface="Times New Roman" panose="02020603050405020304" pitchFamily="18" charset="0"/>
+                <a:cs typeface="Times New Roman" panose="02020603050405020304" pitchFamily="18" charset="0"/>
+              </a:rPr>
+              <a:t>Molecular</a:t>
+            </a:r>
+            <a:r>
+              <a:rPr lang="fr-FR" dirty="0">
+                <a:latin typeface="Times New Roman" panose="02020603050405020304" pitchFamily="18" charset="0"/>
+                <a:cs typeface="Times New Roman" panose="02020603050405020304" pitchFamily="18" charset="0"/>
+              </a:rPr>
+              <a:t> </a:t>
+            </a:r>
+            <a:r>
+              <a:rPr lang="fr-FR" dirty="0" err="1">
+                <a:latin typeface="Times New Roman" panose="02020603050405020304" pitchFamily="18" charset="0"/>
+                <a:cs typeface="Times New Roman" panose="02020603050405020304" pitchFamily="18" charset="0"/>
+              </a:rPr>
+              <a:t>Massively</a:t>
+            </a:r>
+            <a:r>
+              <a:rPr lang="fr-FR" dirty="0">
+                <a:latin typeface="Times New Roman" panose="02020603050405020304" pitchFamily="18" charset="0"/>
+                <a:cs typeface="Times New Roman" panose="02020603050405020304" pitchFamily="18" charset="0"/>
+              </a:rPr>
+              <a:t> </a:t>
+            </a:r>
+            <a:r>
+              <a:rPr lang="fr-FR" dirty="0" err="1">
+                <a:latin typeface="Times New Roman" panose="02020603050405020304" pitchFamily="18" charset="0"/>
+                <a:cs typeface="Times New Roman" panose="02020603050405020304" pitchFamily="18" charset="0"/>
+              </a:rPr>
+              <a:t>Parallel</a:t>
+            </a:r>
+            <a:r>
+              <a:rPr lang="fr-FR" dirty="0">
+                <a:latin typeface="Times New Roman" panose="02020603050405020304" pitchFamily="18" charset="0"/>
+                <a:cs typeface="Times New Roman" panose="02020603050405020304" pitchFamily="18" charset="0"/>
+              </a:rPr>
+              <a:t> Simulator) est un logiciel de simulation utilisé principalement pour la dynamique moléculaire</a:t>
+            </a:r>
+          </a:p>
+        </p:txBody>
+      </p:sp>
+    </p:spTree>
+    <p:extLst>
+      <p:ext uri="{BB962C8B-B14F-4D97-AF65-F5344CB8AC3E}">
+        <p14:creationId xmlns:p14="http://schemas.microsoft.com/office/powerpoint/2010/main" val="26404487"/>
+      </p:ext>
+    </p:extLst>
+  </p:cSld>
+  <p:clrMapOvr>
+    <a:masterClrMapping/>
+  </p:clrMapOvr>
+</p:sld>
+</file>
+
+<file path=ppt/slides/slide8.xml><?xml version="1.0" encoding="utf-8"?>
+<p:sld xmlns:a="http://schemas.openxmlformats.org/drawingml/2006/main" xmlns:r="http://schemas.openxmlformats.org/officeDocument/2006/relationships" xmlns:p="http://schemas.openxmlformats.org/presentationml/2006/main">
+  <p:cSld>
+    <p:spTree>
+      <p:nvGrpSpPr>
+        <p:cNvPr id="1" name=""/>
+        <p:cNvGrpSpPr/>
+        <p:nvPr/>
+      </p:nvGrpSpPr>
+      <p:grpSpPr>
+        <a:xfrm>
+          <a:off x="0" y="0"/>
+          <a:ext cx="0" cy="0"/>
+          <a:chOff x="0" y="0"/>
+          <a:chExt cx="0" cy="0"/>
+        </a:xfrm>
+      </p:grpSpPr>
+      <p:sp>
+        <p:nvSpPr>
+          <p:cNvPr id="2" name="Title 1">
+            <a:extLst>
+              <a:ext uri="{FF2B5EF4-FFF2-40B4-BE49-F238E27FC236}">
+                <a16:creationId xmlns:a16="http://schemas.microsoft.com/office/drawing/2014/main" id="{7415ABBD-1A2D-F356-9F35-4724FB248F14}"/>
+              </a:ext>
+            </a:extLst>
+          </p:cNvPr>
+          <p:cNvSpPr>
+            <a:spLocks noGrp="1"/>
+          </p:cNvSpPr>
+          <p:nvPr>
+            <p:ph type="title"/>
+          </p:nvPr>
+        </p:nvSpPr>
+        <p:spPr/>
+        <p:txBody>
+          <a:bodyPr/>
+          <a:lstStyle/>
+          <a:p>
+            <a:r>
+              <a:rPr lang="en-US" sz="4000" dirty="0"/>
+              <a:t>Structure d’un script LAMMPS</a:t>
+            </a:r>
+            <a:endParaRPr lang="fr-FR" sz="4000" dirty="0"/>
+          </a:p>
+        </p:txBody>
+      </p:sp>
+      <p:sp>
+        <p:nvSpPr>
+          <p:cNvPr id="3" name="Content Placeholder 2">
+            <a:extLst>
+              <a:ext uri="{FF2B5EF4-FFF2-40B4-BE49-F238E27FC236}">
+                <a16:creationId xmlns:a16="http://schemas.microsoft.com/office/drawing/2014/main" id="{AB9BDD53-12E9-5E79-1CE6-8A3D1C158096}"/>
+              </a:ext>
+            </a:extLst>
+          </p:cNvPr>
+          <p:cNvSpPr>
+            <a:spLocks noGrp="1"/>
+          </p:cNvSpPr>
+          <p:nvPr>
+            <p:ph idx="1"/>
+          </p:nvPr>
+        </p:nvSpPr>
+        <p:spPr>
+          <a:xfrm>
+            <a:off x="249288" y="1484784"/>
+            <a:ext cx="8640960" cy="3240359"/>
+          </a:xfrm>
+        </p:spPr>
+        <p:txBody>
+          <a:bodyPr/>
+          <a:lstStyle/>
+          <a:p>
+            <a:pPr algn="just">
+              <a:lnSpc>
+                <a:spcPct val="150000"/>
+              </a:lnSpc>
+            </a:pPr>
+            <a:r>
+              <a:rPr lang="en-US" dirty="0" err="1"/>
+              <a:t>Initialisation</a:t>
+            </a:r>
+            <a:r>
+              <a:rPr lang="en-US" dirty="0"/>
+              <a:t> et conditions </a:t>
+            </a:r>
+            <a:r>
+              <a:rPr lang="en-US" dirty="0" err="1"/>
+              <a:t>initiales</a:t>
+            </a:r>
+            <a:endParaRPr lang="en-US" dirty="0"/>
+          </a:p>
+          <a:p>
+            <a:pPr algn="just">
+              <a:lnSpc>
+                <a:spcPct val="150000"/>
+              </a:lnSpc>
+            </a:pPr>
+            <a:r>
+              <a:rPr lang="en-US" dirty="0" err="1"/>
+              <a:t>Paramétrage</a:t>
+            </a:r>
+            <a:r>
+              <a:rPr lang="en-US" dirty="0"/>
+              <a:t> de </a:t>
+            </a:r>
+            <a:r>
+              <a:rPr lang="en-US" dirty="0" err="1"/>
+              <a:t>l'évolution</a:t>
+            </a:r>
+            <a:r>
+              <a:rPr lang="en-US" dirty="0"/>
+              <a:t> du </a:t>
+            </a:r>
+            <a:r>
+              <a:rPr lang="en-US" dirty="0" err="1"/>
+              <a:t>système</a:t>
+            </a:r>
+            <a:endParaRPr lang="en-US" dirty="0"/>
+          </a:p>
+          <a:p>
+            <a:pPr algn="just">
+              <a:lnSpc>
+                <a:spcPct val="150000"/>
+              </a:lnSpc>
+            </a:pPr>
+            <a:r>
+              <a:rPr lang="en-US" dirty="0" err="1"/>
+              <a:t>Définitions</a:t>
+            </a:r>
+            <a:r>
+              <a:rPr lang="en-US" dirty="0"/>
+              <a:t> des </a:t>
+            </a:r>
+            <a:r>
+              <a:rPr lang="en-US" dirty="0" err="1"/>
+              <a:t>informations</a:t>
+            </a:r>
+            <a:r>
+              <a:rPr lang="en-US" dirty="0"/>
+              <a:t> à exporter</a:t>
+            </a:r>
+          </a:p>
+          <a:p>
+            <a:pPr algn="just">
+              <a:lnSpc>
+                <a:spcPct val="150000"/>
+              </a:lnSpc>
+            </a:pPr>
+            <a:r>
+              <a:rPr lang="en-US" dirty="0" err="1"/>
+              <a:t>Paramétrage</a:t>
+            </a:r>
+            <a:r>
+              <a:rPr lang="en-US" dirty="0"/>
+              <a:t> du cycle CRC et choix du thermostat</a:t>
+            </a:r>
+            <a:endParaRPr lang="fr-FR" dirty="0"/>
+          </a:p>
+        </p:txBody>
+      </p:sp>
+      <p:sp>
+        <p:nvSpPr>
+          <p:cNvPr id="4" name="Footer Placeholder 3">
+            <a:extLst>
+              <a:ext uri="{FF2B5EF4-FFF2-40B4-BE49-F238E27FC236}">
+                <a16:creationId xmlns:a16="http://schemas.microsoft.com/office/drawing/2014/main" id="{378C702F-D50C-60C3-82D8-6CE9F154AF24}"/>
+              </a:ext>
+            </a:extLst>
+          </p:cNvPr>
+          <p:cNvSpPr>
+            <a:spLocks noGrp="1"/>
+          </p:cNvSpPr>
+          <p:nvPr>
+            <p:ph type="ftr" sz="quarter" idx="11"/>
+          </p:nvPr>
+        </p:nvSpPr>
+        <p:spPr/>
+        <p:txBody>
+          <a:bodyPr/>
+          <a:lstStyle/>
+          <a:p>
+            <a:r>
+              <a:rPr lang="fr-FR"/>
+              <a:t>CONFERENCE - Ville, Pays - Date</a:t>
+            </a:r>
+            <a:endParaRPr lang="fr-FR" dirty="0"/>
+          </a:p>
+        </p:txBody>
+      </p:sp>
+      <p:sp>
+        <p:nvSpPr>
+          <p:cNvPr id="5" name="Slide Number Placeholder 4">
+            <a:extLst>
+              <a:ext uri="{FF2B5EF4-FFF2-40B4-BE49-F238E27FC236}">
+                <a16:creationId xmlns:a16="http://schemas.microsoft.com/office/drawing/2014/main" id="{ACF166B2-591D-7C1A-BCFE-E60A1945E3B1}"/>
+              </a:ext>
+            </a:extLst>
+          </p:cNvPr>
+          <p:cNvSpPr>
+            <a:spLocks noGrp="1"/>
+          </p:cNvSpPr>
+          <p:nvPr>
+            <p:ph type="sldNum" sz="quarter" idx="12"/>
+          </p:nvPr>
+        </p:nvSpPr>
+        <p:spPr/>
+        <p:txBody>
+          <a:bodyPr/>
+          <a:lstStyle/>
+          <a:p>
+            <a:fld id="{BCB85A95-E1CC-4DC7-938C-5BF234670505}" type="slidenum">
+              <a:rPr lang="fr-FR" smtClean="0"/>
+              <a:pPr/>
+              <a:t>8</a:t>
+            </a:fld>
+            <a:endParaRPr lang="fr-FR"/>
+          </a:p>
+        </p:txBody>
+      </p:sp>
+    </p:spTree>
+    <p:extLst>
+      <p:ext uri="{BB962C8B-B14F-4D97-AF65-F5344CB8AC3E}">
+        <p14:creationId xmlns:p14="http://schemas.microsoft.com/office/powerpoint/2010/main" val="1116658262"/>
+      </p:ext>
+    </p:extLst>
+  </p:cSld>
+  <p:clrMapOvr>
+    <a:masterClrMapping/>
+  </p:clrMapOvr>
+</p:sld>
+</file>
+
+<file path=ppt/slides/slide9.xml><?xml version="1.0" encoding="utf-8"?>
+<p:sld xmlns:a="http://schemas.openxmlformats.org/drawingml/2006/main" xmlns:r="http://schemas.openxmlformats.org/officeDocument/2006/relationships" xmlns:p="http://schemas.openxmlformats.org/presentationml/2006/main">
+  <p:cSld>
+    <p:spTree>
+      <p:nvGrpSpPr>
+        <p:cNvPr id="1" name=""/>
+        <p:cNvGrpSpPr/>
+        <p:nvPr/>
+      </p:nvGrpSpPr>
+      <p:grpSpPr>
+        <a:xfrm>
+          <a:off x="0" y="0"/>
+          <a:ext cx="0" cy="0"/>
+          <a:chOff x="0" y="0"/>
+          <a:chExt cx="0" cy="0"/>
+        </a:xfrm>
+      </p:grpSpPr>
+      <p:sp>
+        <p:nvSpPr>
+          <p:cNvPr id="2" name="Title 1">
+            <a:extLst>
+              <a:ext uri="{FF2B5EF4-FFF2-40B4-BE49-F238E27FC236}">
+                <a16:creationId xmlns:a16="http://schemas.microsoft.com/office/drawing/2014/main" id="{A60B19D1-7557-C9AA-368A-3EC99E93E072}"/>
+              </a:ext>
+            </a:extLst>
+          </p:cNvPr>
+          <p:cNvSpPr>
+            <a:spLocks noGrp="1"/>
+          </p:cNvSpPr>
+          <p:nvPr>
+            <p:ph type="title"/>
+          </p:nvPr>
+        </p:nvSpPr>
+        <p:spPr>
+          <a:xfrm>
+            <a:off x="323528" y="188640"/>
+            <a:ext cx="8568952" cy="792088"/>
+          </a:xfrm>
+        </p:spPr>
+        <p:txBody>
+          <a:bodyPr wrap="square" anchor="b">
+            <a:normAutofit/>
+          </a:bodyPr>
+          <a:lstStyle/>
+          <a:p>
+            <a:pPr>
+              <a:lnSpc>
+                <a:spcPct val="90000"/>
+              </a:lnSpc>
+            </a:pPr>
+            <a:r>
+              <a:rPr lang="en-US" sz="2800" dirty="0" err="1"/>
+              <a:t>Paramètres</a:t>
+            </a:r>
+            <a:r>
+              <a:rPr lang="en-US" sz="2800" dirty="0"/>
+              <a:t> des calculs de la </a:t>
+            </a:r>
+            <a:r>
+              <a:rPr lang="en-US" sz="2800" dirty="0" err="1"/>
+              <a:t>docteure</a:t>
+            </a:r>
+            <a:r>
+              <a:rPr lang="en-US" sz="2800" dirty="0"/>
+              <a:t> </a:t>
+            </a:r>
+            <a:r>
+              <a:rPr lang="en-US" sz="2800" dirty="0" err="1"/>
+              <a:t>Allouch</a:t>
+            </a:r>
+            <a:endParaRPr lang="fr-FR" sz="2800"/>
+          </a:p>
+        </p:txBody>
+      </p:sp>
+      <p:graphicFrame>
+        <p:nvGraphicFramePr>
+          <p:cNvPr id="11" name="Content Placeholder 10">
+            <a:extLst>
+              <a:ext uri="{FF2B5EF4-FFF2-40B4-BE49-F238E27FC236}">
+                <a16:creationId xmlns:a16="http://schemas.microsoft.com/office/drawing/2014/main" id="{EA1E68E6-9100-F48C-EEB3-C680038A28AE}"/>
+              </a:ext>
+            </a:extLst>
+          </p:cNvPr>
+          <p:cNvGraphicFramePr>
+            <a:graphicFrameLocks/>
+          </p:cNvGraphicFramePr>
+          <p:nvPr>
+            <p:ph sz="half" idx="1"/>
+            <p:extLst>
+              <p:ext uri="{D42A27DB-BD31-4B8C-83A1-F6EECF244321}">
+                <p14:modId xmlns:p14="http://schemas.microsoft.com/office/powerpoint/2010/main" val="1433122172"/>
+              </p:ext>
+            </p:extLst>
+          </p:nvPr>
+        </p:nvGraphicFramePr>
+        <p:xfrm>
+          <a:off x="250825" y="1270000"/>
+          <a:ext cx="4244974" cy="4790452"/>
+        </p:xfrm>
+        <a:graphic>
+          <a:graphicData uri="http://schemas.openxmlformats.org/drawingml/2006/table">
+            <a:tbl>
+              <a:tblPr firstCol="1" bandRow="1">
+                <a:effectLst>
+                  <a:outerShdw blurRad="50800" dist="38100" dir="2700000" algn="tl" rotWithShape="0">
+                    <a:prstClr val="black">
+                      <a:alpha val="40000"/>
+                    </a:prstClr>
+                  </a:outerShdw>
+                </a:effectLst>
+                <a:tableStyleId>{8A107856-5554-42FB-B03E-39F5DBC370BA}</a:tableStyleId>
+              </a:tblPr>
+              <a:tblGrid>
+                <a:gridCol w="2122487">
+                  <a:extLst>
+                    <a:ext uri="{9D8B030D-6E8A-4147-A177-3AD203B41FA5}">
+                      <a16:colId xmlns:a16="http://schemas.microsoft.com/office/drawing/2014/main" val="1922877863"/>
+                    </a:ext>
+                  </a:extLst>
+                </a:gridCol>
+                <a:gridCol w="2122487">
+                  <a:extLst>
+                    <a:ext uri="{9D8B030D-6E8A-4147-A177-3AD203B41FA5}">
+                      <a16:colId xmlns:a16="http://schemas.microsoft.com/office/drawing/2014/main" val="1022982593"/>
+                    </a:ext>
+                  </a:extLst>
+                </a:gridCol>
+              </a:tblGrid>
+              <a:tr h="790848">
+                <a:tc>
+                  <a:txBody>
+                    <a:bodyPr/>
+                    <a:lstStyle/>
+                    <a:p>
+                      <a:r>
+                        <a:rPr lang="en-US" dirty="0" err="1"/>
+                        <a:t>Unités</a:t>
+                      </a:r>
+                      <a:r>
+                        <a:rPr lang="en-US" dirty="0"/>
+                        <a:t> de mesure</a:t>
+                      </a:r>
+                      <a:endParaRPr lang="fr-FR" dirty="0"/>
+                    </a:p>
+                  </a:txBody>
+                  <a:tcPr/>
+                </a:tc>
+                <a:tc>
+                  <a:txBody>
+                    <a:bodyPr/>
+                    <a:lstStyle/>
+                    <a:p>
+                      <a:r>
+                        <a:rPr lang="en-US" b="0" dirty="0"/>
+                        <a:t>Ps, Angstrom, grams/mole, eV, K</a:t>
+                      </a:r>
+                      <a:endParaRPr lang="fr-FR" b="0" dirty="0"/>
+                    </a:p>
+                  </a:txBody>
+                  <a:tcPr/>
+                </a:tc>
+                <a:extLst>
+                  <a:ext uri="{0D108BD9-81ED-4DB2-BD59-A6C34878D82A}">
+                    <a16:rowId xmlns:a16="http://schemas.microsoft.com/office/drawing/2014/main" val="1285080163"/>
+                  </a:ext>
+                </a:extLst>
+              </a:tr>
+              <a:tr h="759244">
+                <a:tc>
+                  <a:txBody>
+                    <a:bodyPr/>
+                    <a:lstStyle/>
+                    <a:p>
+                      <a:r>
+                        <a:rPr lang="en-US" b="1" dirty="0" err="1"/>
+                        <a:t>Boîte</a:t>
+                      </a:r>
+                      <a:r>
+                        <a:rPr lang="en-US" b="1" dirty="0"/>
+                        <a:t> de simulation</a:t>
+                      </a:r>
+                      <a:endParaRPr lang="fr-FR" b="1" dirty="0"/>
+                    </a:p>
+                  </a:txBody>
+                  <a:tcPr/>
+                </a:tc>
+                <a:tc>
+                  <a:txBody>
+                    <a:bodyPr/>
+                    <a:lstStyle/>
+                    <a:p>
+                      <a:r>
+                        <a:rPr lang="en-US" dirty="0"/>
+                        <a:t>(100 Angstroms)</a:t>
+                      </a:r>
+                      <a:r>
+                        <a:rPr lang="en-US" baseline="30000" dirty="0"/>
+                        <a:t>3</a:t>
+                      </a:r>
+                      <a:endParaRPr lang="fr-FR" dirty="0"/>
+                    </a:p>
+                  </a:txBody>
+                  <a:tcPr/>
+                </a:tc>
+                <a:extLst>
+                  <a:ext uri="{0D108BD9-81ED-4DB2-BD59-A6C34878D82A}">
+                    <a16:rowId xmlns:a16="http://schemas.microsoft.com/office/drawing/2014/main" val="957295555"/>
+                  </a:ext>
+                </a:extLst>
+              </a:tr>
+              <a:tr h="824932">
+                <a:tc>
+                  <a:txBody>
+                    <a:bodyPr/>
+                    <a:lstStyle/>
+                    <a:p>
+                      <a:r>
+                        <a:rPr lang="en-US" b="1" dirty="0"/>
+                        <a:t>Volume initial</a:t>
+                      </a:r>
+                      <a:endParaRPr lang="fr-FR" b="1" dirty="0"/>
+                    </a:p>
+                  </a:txBody>
+                  <a:tcPr/>
+                </a:tc>
+                <a:tc>
+                  <a:txBody>
+                    <a:bodyPr/>
+                    <a:lstStyle/>
+                    <a:p>
+                      <a:r>
+                        <a:rPr lang="en-US" dirty="0"/>
+                        <a:t>(20 Angstroms)</a:t>
+                      </a:r>
+                      <a:r>
+                        <a:rPr lang="en-US" baseline="30000" dirty="0"/>
+                        <a:t>3</a:t>
+                      </a:r>
+                      <a:endParaRPr lang="fr-FR" dirty="0"/>
+                    </a:p>
+                  </a:txBody>
+                  <a:tcPr/>
+                </a:tc>
+                <a:extLst>
+                  <a:ext uri="{0D108BD9-81ED-4DB2-BD59-A6C34878D82A}">
+                    <a16:rowId xmlns:a16="http://schemas.microsoft.com/office/drawing/2014/main" val="1037692208"/>
+                  </a:ext>
+                </a:extLst>
+              </a:tr>
+              <a:tr h="759244">
+                <a:tc>
+                  <a:txBody>
+                    <a:bodyPr/>
+                    <a:lstStyle/>
+                    <a:p>
+                      <a:r>
+                        <a:rPr lang="en-US" b="1" dirty="0"/>
+                        <a:t>Thermostat</a:t>
+                      </a:r>
+                      <a:endParaRPr lang="fr-FR" b="1" dirty="0"/>
+                    </a:p>
+                  </a:txBody>
+                  <a:tcPr/>
+                </a:tc>
+                <a:tc>
+                  <a:txBody>
+                    <a:bodyPr/>
+                    <a:lstStyle/>
+                    <a:p>
+                      <a:r>
+                        <a:rPr lang="en-US" dirty="0"/>
+                        <a:t>Berendsen</a:t>
+                      </a:r>
+                      <a:endParaRPr lang="fr-FR" dirty="0"/>
+                    </a:p>
+                  </a:txBody>
+                  <a:tcPr/>
+                </a:tc>
+                <a:extLst>
+                  <a:ext uri="{0D108BD9-81ED-4DB2-BD59-A6C34878D82A}">
+                    <a16:rowId xmlns:a16="http://schemas.microsoft.com/office/drawing/2014/main" val="3846783697"/>
+                  </a:ext>
+                </a:extLst>
+              </a:tr>
+              <a:tr h="896940">
+                <a:tc>
+                  <a:txBody>
+                    <a:bodyPr/>
+                    <a:lstStyle/>
+                    <a:p>
+                      <a:r>
+                        <a:rPr lang="en-US" b="1" dirty="0" err="1"/>
+                        <a:t>Tmin</a:t>
+                      </a:r>
+                      <a:r>
+                        <a:rPr lang="en-US" b="1" dirty="0"/>
+                        <a:t>, </a:t>
+                      </a:r>
+                      <a:r>
+                        <a:rPr lang="en-US" b="1" dirty="0" err="1"/>
+                        <a:t>Tmax</a:t>
+                      </a:r>
+                      <a:endParaRPr lang="fr-FR" b="1" dirty="0"/>
+                    </a:p>
+                  </a:txBody>
+                  <a:tcPr/>
+                </a:tc>
+                <a:tc>
+                  <a:txBody>
+                    <a:bodyPr/>
+                    <a:lstStyle/>
+                    <a:p>
+                      <a:r>
+                        <a:rPr lang="en-US" dirty="0"/>
+                        <a:t>0, 3000 K</a:t>
+                      </a:r>
+                      <a:endParaRPr lang="fr-FR" dirty="0"/>
+                    </a:p>
+                  </a:txBody>
+                  <a:tcPr/>
+                </a:tc>
+                <a:extLst>
+                  <a:ext uri="{0D108BD9-81ED-4DB2-BD59-A6C34878D82A}">
+                    <a16:rowId xmlns:a16="http://schemas.microsoft.com/office/drawing/2014/main" val="1216744493"/>
+                  </a:ext>
+                </a:extLst>
+              </a:tr>
+              <a:tr h="759244">
+                <a:tc>
+                  <a:txBody>
+                    <a:bodyPr/>
+                    <a:lstStyle/>
+                    <a:p>
+                      <a:r>
+                        <a:rPr lang="en-US" b="1" dirty="0"/>
+                        <a:t>Position </a:t>
+                      </a:r>
+                      <a:r>
+                        <a:rPr lang="en-US" b="1" dirty="0" err="1"/>
+                        <a:t>initiale</a:t>
+                      </a:r>
+                      <a:r>
+                        <a:rPr lang="en-US" b="1" dirty="0"/>
+                        <a:t> (seed)</a:t>
+                      </a:r>
+                      <a:endParaRPr lang="fr-FR" b="1" dirty="0"/>
+                    </a:p>
+                  </a:txBody>
+                  <a:tcPr/>
+                </a:tc>
+                <a:tc>
+                  <a:txBody>
+                    <a:bodyPr/>
+                    <a:lstStyle/>
+                    <a:p>
+                      <a:r>
+                        <a:rPr lang="en-US" dirty="0" err="1"/>
+                        <a:t>Aléatoire</a:t>
+                      </a:r>
+                      <a:r>
+                        <a:rPr lang="en-US" dirty="0"/>
+                        <a:t> </a:t>
+                      </a:r>
+                      <a:endParaRPr lang="fr-FR" dirty="0"/>
+                    </a:p>
+                  </a:txBody>
+                  <a:tcPr/>
+                </a:tc>
+                <a:extLst>
+                  <a:ext uri="{0D108BD9-81ED-4DB2-BD59-A6C34878D82A}">
+                    <a16:rowId xmlns:a16="http://schemas.microsoft.com/office/drawing/2014/main" val="2313159066"/>
+                  </a:ext>
+                </a:extLst>
+              </a:tr>
+            </a:tbl>
+          </a:graphicData>
+        </a:graphic>
+      </p:graphicFrame>
+      <p:sp>
+        <p:nvSpPr>
+          <p:cNvPr id="4" name="Footer Placeholder 3">
+            <a:extLst>
+              <a:ext uri="{FF2B5EF4-FFF2-40B4-BE49-F238E27FC236}">
+                <a16:creationId xmlns:a16="http://schemas.microsoft.com/office/drawing/2014/main" id="{C7F68FE4-065B-8261-21CD-29BB173E8199}"/>
+              </a:ext>
+            </a:extLst>
+          </p:cNvPr>
+          <p:cNvSpPr>
+            <a:spLocks noGrp="1"/>
+          </p:cNvSpPr>
+          <p:nvPr>
+            <p:ph type="ftr" sz="quarter" idx="11"/>
+          </p:nvPr>
+        </p:nvSpPr>
+        <p:spPr>
+          <a:xfrm>
+            <a:off x="2627784" y="6356350"/>
+            <a:ext cx="5400600" cy="365125"/>
+          </a:xfrm>
+        </p:spPr>
+        <p:txBody>
+          <a:bodyPr anchor="ctr">
+            <a:normAutofit/>
+          </a:bodyPr>
+          <a:lstStyle/>
+          <a:p>
+            <a:pPr>
+              <a:spcAft>
+                <a:spcPts val="600"/>
+              </a:spcAft>
+            </a:pPr>
+            <a:r>
+              <a:rPr lang="fr-FR"/>
+              <a:t>CONFERENCE - Ville, Pays - Date</a:t>
+            </a:r>
+          </a:p>
+        </p:txBody>
+      </p:sp>
+      <p:sp>
+        <p:nvSpPr>
+          <p:cNvPr id="5" name="Slide Number Placeholder 4">
+            <a:extLst>
+              <a:ext uri="{FF2B5EF4-FFF2-40B4-BE49-F238E27FC236}">
+                <a16:creationId xmlns:a16="http://schemas.microsoft.com/office/drawing/2014/main" id="{6A50C25A-C820-7033-FB95-4C14B3461CBA}"/>
+              </a:ext>
+            </a:extLst>
+          </p:cNvPr>
+          <p:cNvSpPr>
+            <a:spLocks noGrp="1"/>
+          </p:cNvSpPr>
+          <p:nvPr>
+            <p:ph type="sldNum" sz="quarter" idx="12"/>
+          </p:nvPr>
+        </p:nvSpPr>
+        <p:spPr>
+          <a:xfrm>
+            <a:off x="8172400" y="6356350"/>
+            <a:ext cx="717848" cy="365125"/>
+          </a:xfrm>
+        </p:spPr>
+        <p:txBody>
+          <a:bodyPr anchor="ctr">
+            <a:normAutofit/>
+          </a:bodyPr>
+          <a:lstStyle/>
+          <a:p>
+            <a:pPr>
+              <a:spcAft>
+                <a:spcPts val="600"/>
+              </a:spcAft>
+            </a:pPr>
+            <a:fld id="{BCB85A95-E1CC-4DC7-938C-5BF234670505}" type="slidenum">
+              <a:rPr lang="fr-FR" smtClean="0"/>
+              <a:pPr>
+                <a:spcAft>
+                  <a:spcPts val="600"/>
+                </a:spcAft>
+              </a:pPr>
+              <a:t>9</a:t>
+            </a:fld>
+            <a:endParaRPr lang="fr-FR"/>
+          </a:p>
+        </p:txBody>
+      </p:sp>
+      <p:graphicFrame>
+        <p:nvGraphicFramePr>
+          <p:cNvPr id="13" name="Content Placeholder 12">
+            <a:extLst>
+              <a:ext uri="{FF2B5EF4-FFF2-40B4-BE49-F238E27FC236}">
+                <a16:creationId xmlns:a16="http://schemas.microsoft.com/office/drawing/2014/main" id="{0FA52BE1-301B-6B99-E010-C3A26A7F4657}"/>
+              </a:ext>
+            </a:extLst>
+          </p:cNvPr>
+          <p:cNvGraphicFramePr>
+            <a:graphicFrameLocks/>
+          </p:cNvGraphicFramePr>
+          <p:nvPr>
+            <p:ph sz="half" idx="2"/>
+            <p:extLst>
+              <p:ext uri="{D42A27DB-BD31-4B8C-83A1-F6EECF244321}">
+                <p14:modId xmlns:p14="http://schemas.microsoft.com/office/powerpoint/2010/main" val="3793723635"/>
+              </p:ext>
+            </p:extLst>
+          </p:nvPr>
+        </p:nvGraphicFramePr>
+        <p:xfrm>
+          <a:off x="4648200" y="1270000"/>
+          <a:ext cx="4244974" cy="4808705"/>
+        </p:xfrm>
+        <a:graphic>
+          <a:graphicData uri="http://schemas.openxmlformats.org/drawingml/2006/table">
+            <a:tbl>
+              <a:tblPr firstCol="1" bandRow="1">
+                <a:effectLst>
+                  <a:outerShdw blurRad="50800" dist="38100" dir="2700000" algn="tl" rotWithShape="0">
+                    <a:prstClr val="black">
+                      <a:alpha val="40000"/>
+                    </a:prstClr>
+                  </a:outerShdw>
+                </a:effectLst>
+                <a:tableStyleId>{8A107856-5554-42FB-B03E-39F5DBC370BA}</a:tableStyleId>
+              </a:tblPr>
+              <a:tblGrid>
+                <a:gridCol w="2122487">
+                  <a:extLst>
+                    <a:ext uri="{9D8B030D-6E8A-4147-A177-3AD203B41FA5}">
+                      <a16:colId xmlns:a16="http://schemas.microsoft.com/office/drawing/2014/main" val="823330606"/>
+                    </a:ext>
+                  </a:extLst>
+                </a:gridCol>
+                <a:gridCol w="2122487">
+                  <a:extLst>
+                    <a:ext uri="{9D8B030D-6E8A-4147-A177-3AD203B41FA5}">
+                      <a16:colId xmlns:a16="http://schemas.microsoft.com/office/drawing/2014/main" val="2630531319"/>
+                    </a:ext>
+                  </a:extLst>
+                </a:gridCol>
+              </a:tblGrid>
+              <a:tr h="778861">
+                <a:tc>
+                  <a:txBody>
+                    <a:bodyPr/>
+                    <a:lstStyle/>
+                    <a:p>
+                      <a:r>
+                        <a:rPr lang="en-US" dirty="0"/>
+                        <a:t>Conditions aux </a:t>
+                      </a:r>
+                      <a:r>
+                        <a:rPr lang="en-US" dirty="0" err="1"/>
+                        <a:t>limites</a:t>
+                      </a:r>
+                      <a:endParaRPr lang="fr-FR" dirty="0"/>
+                    </a:p>
+                  </a:txBody>
+                  <a:tcPr/>
+                </a:tc>
+                <a:tc>
+                  <a:txBody>
+                    <a:bodyPr/>
+                    <a:lstStyle/>
+                    <a:p>
+                      <a:r>
+                        <a:rPr lang="en-US" b="0" dirty="0" err="1"/>
+                        <a:t>Périodique</a:t>
+                      </a:r>
+                      <a:endParaRPr lang="fr-FR" b="0" dirty="0"/>
+                    </a:p>
+                  </a:txBody>
+                  <a:tcPr/>
+                </a:tc>
+                <a:extLst>
+                  <a:ext uri="{0D108BD9-81ED-4DB2-BD59-A6C34878D82A}">
+                    <a16:rowId xmlns:a16="http://schemas.microsoft.com/office/drawing/2014/main" val="998257242"/>
+                  </a:ext>
+                </a:extLst>
+              </a:tr>
+              <a:tr h="778861">
+                <a:tc>
+                  <a:txBody>
+                    <a:bodyPr/>
+                    <a:lstStyle/>
+                    <a:p>
+                      <a:r>
+                        <a:rPr lang="en-US" b="1" dirty="0" err="1"/>
+                        <a:t>Potentiel</a:t>
+                      </a:r>
+                      <a:endParaRPr lang="fr-FR" b="1" dirty="0"/>
+                    </a:p>
+                  </a:txBody>
+                  <a:tcPr/>
+                </a:tc>
+                <a:tc>
+                  <a:txBody>
+                    <a:bodyPr/>
+                    <a:lstStyle/>
+                    <a:p>
+                      <a:r>
+                        <a:rPr lang="en-US" dirty="0" err="1"/>
+                        <a:t>Rebo</a:t>
+                      </a:r>
+                      <a:endParaRPr lang="fr-FR" dirty="0"/>
+                    </a:p>
+                  </a:txBody>
+                  <a:tcPr/>
+                </a:tc>
+                <a:extLst>
+                  <a:ext uri="{0D108BD9-81ED-4DB2-BD59-A6C34878D82A}">
+                    <a16:rowId xmlns:a16="http://schemas.microsoft.com/office/drawing/2014/main" val="3971969892"/>
+                  </a:ext>
+                </a:extLst>
+              </a:tr>
+              <a:tr h="778861">
+                <a:tc>
+                  <a:txBody>
+                    <a:bodyPr/>
+                    <a:lstStyle/>
+                    <a:p>
+                      <a:r>
+                        <a:rPr lang="en-US" b="1" dirty="0" err="1"/>
+                        <a:t>Sélection</a:t>
+                      </a:r>
+                      <a:r>
+                        <a:rPr lang="en-US" b="1" dirty="0"/>
+                        <a:t> des </a:t>
+                      </a:r>
+                      <a:r>
+                        <a:rPr lang="en-US" b="1" dirty="0" err="1"/>
+                        <a:t>voisins</a:t>
+                      </a:r>
+                      <a:r>
+                        <a:rPr lang="en-US" b="1" dirty="0"/>
+                        <a:t> et skin</a:t>
+                      </a:r>
+                      <a:endParaRPr lang="fr-FR" b="1" dirty="0"/>
+                    </a:p>
+                  </a:txBody>
+                  <a:tcPr/>
+                </a:tc>
+                <a:tc>
+                  <a:txBody>
+                    <a:bodyPr/>
+                    <a:lstStyle/>
+                    <a:p>
+                      <a:r>
+                        <a:rPr lang="en-US" dirty="0"/>
+                        <a:t>Bin, 0.3</a:t>
+                      </a:r>
+                      <a:endParaRPr lang="fr-FR" dirty="0"/>
+                    </a:p>
+                  </a:txBody>
+                  <a:tcPr/>
+                </a:tc>
+                <a:extLst>
+                  <a:ext uri="{0D108BD9-81ED-4DB2-BD59-A6C34878D82A}">
+                    <a16:rowId xmlns:a16="http://schemas.microsoft.com/office/drawing/2014/main" val="1881913107"/>
+                  </a:ext>
+                </a:extLst>
+              </a:tr>
+              <a:tr h="778861">
+                <a:tc>
+                  <a:txBody>
+                    <a:bodyPr/>
+                    <a:lstStyle/>
+                    <a:p>
+                      <a:r>
+                        <a:rPr lang="en-US" b="1" dirty="0" err="1"/>
+                        <a:t>Environnement</a:t>
+                      </a:r>
+                      <a:r>
+                        <a:rPr lang="en-US" b="1" dirty="0"/>
+                        <a:t> de </a:t>
+                      </a:r>
+                      <a:r>
+                        <a:rPr lang="en-US" b="1" dirty="0" err="1"/>
+                        <a:t>calcul</a:t>
+                      </a:r>
+                      <a:endParaRPr lang="fr-FR" b="1" dirty="0"/>
+                    </a:p>
+                  </a:txBody>
+                  <a:tcPr/>
+                </a:tc>
+                <a:tc>
+                  <a:txBody>
+                    <a:bodyPr/>
+                    <a:lstStyle/>
+                    <a:p>
+                      <a:r>
+                        <a:rPr lang="en-US" dirty="0" err="1"/>
+                        <a:t>Tchenla</a:t>
+                      </a:r>
+                      <a:endParaRPr lang="fr-FR" dirty="0"/>
+                    </a:p>
+                  </a:txBody>
+                  <a:tcPr/>
+                </a:tc>
+                <a:extLst>
+                  <a:ext uri="{0D108BD9-81ED-4DB2-BD59-A6C34878D82A}">
+                    <a16:rowId xmlns:a16="http://schemas.microsoft.com/office/drawing/2014/main" val="1681489432"/>
+                  </a:ext>
+                </a:extLst>
+              </a:tr>
+              <a:tr h="902773">
+                <a:tc>
+                  <a:txBody>
+                    <a:bodyPr/>
+                    <a:lstStyle/>
+                    <a:p>
+                      <a:r>
+                        <a:rPr lang="en-US" b="1" dirty="0"/>
+                        <a:t>Versions de LAMMPS</a:t>
+                      </a:r>
+                      <a:endParaRPr lang="fr-FR" b="1" dirty="0"/>
+                    </a:p>
+                  </a:txBody>
+                  <a:tcPr/>
+                </a:tc>
+                <a:tc>
+                  <a:txBody>
+                    <a:bodyPr/>
+                    <a:lstStyle/>
+                    <a:p>
+                      <a:pPr marL="285750" indent="-285750">
+                        <a:buFontTx/>
+                        <a:buChar char="-"/>
+                      </a:pPr>
+                      <a:r>
+                        <a:rPr lang="fr-FR" dirty="0"/>
+                        <a:t>16 mars 2018</a:t>
+                      </a:r>
+                    </a:p>
+                    <a:p>
+                      <a:pPr marL="0" indent="0">
+                        <a:buFontTx/>
+                        <a:buNone/>
+                      </a:pPr>
+                      <a:r>
+                        <a:rPr lang="fr-FR" dirty="0"/>
+                        <a:t>-    22 aout 2018</a:t>
+                      </a:r>
+                    </a:p>
+                    <a:p>
+                      <a:pPr marL="285750" indent="-285750">
+                        <a:buFontTx/>
+                        <a:buChar char="-"/>
+                      </a:pPr>
+                      <a:r>
+                        <a:rPr lang="fr-FR" dirty="0"/>
+                        <a:t>3 mars 2020</a:t>
+                      </a:r>
+                    </a:p>
+                  </a:txBody>
+                  <a:tcPr/>
+                </a:tc>
+                <a:extLst>
+                  <a:ext uri="{0D108BD9-81ED-4DB2-BD59-A6C34878D82A}">
+                    <a16:rowId xmlns:a16="http://schemas.microsoft.com/office/drawing/2014/main" val="1909538057"/>
+                  </a:ext>
+                </a:extLst>
+              </a:tr>
+              <a:tr h="778861">
+                <a:tc>
+                  <a:txBody>
+                    <a:bodyPr/>
+                    <a:lstStyle/>
+                    <a:p>
+                      <a:r>
+                        <a:rPr lang="en-US" b="1" dirty="0"/>
+                        <a:t>Durée des phases</a:t>
+                      </a:r>
+                      <a:endParaRPr lang="fr-FR" b="1" dirty="0"/>
+                    </a:p>
+                  </a:txBody>
+                  <a:tcPr/>
+                </a:tc>
+                <a:tc>
+                  <a:txBody>
+                    <a:bodyPr/>
+                    <a:lstStyle/>
+                    <a:p>
+                      <a:r>
+                        <a:rPr lang="en-US" dirty="0"/>
+                        <a:t>100 ns, 100 </a:t>
+                      </a:r>
+                      <a:r>
+                        <a:rPr lang="en-US" dirty="0" err="1"/>
+                        <a:t>ps</a:t>
+                      </a:r>
+                      <a:endParaRPr lang="fr-FR" dirty="0"/>
+                    </a:p>
+                  </a:txBody>
+                  <a:tcPr/>
+                </a:tc>
+                <a:extLst>
+                  <a:ext uri="{0D108BD9-81ED-4DB2-BD59-A6C34878D82A}">
+                    <a16:rowId xmlns:a16="http://schemas.microsoft.com/office/drawing/2014/main" val="552262809"/>
+                  </a:ext>
+                </a:extLst>
+              </a:tr>
+            </a:tbl>
+          </a:graphicData>
+        </a:graphic>
+      </p:graphicFrame>
+    </p:spTree>
+    <p:extLst>
+      <p:ext uri="{BB962C8B-B14F-4D97-AF65-F5344CB8AC3E}">
+        <p14:creationId xmlns:p14="http://schemas.microsoft.com/office/powerpoint/2010/main" val="3557239589"/>
+      </p:ext>
+    </p:extLst>
+  </p:cSld>
+  <p:clrMapOvr>
+    <a:masterClrMapping/>
+  </p:clrMapOvr>
 </p:sld>
 </file>
 

</xml_diff>